<commit_message>
Fix creative template QA root causes
Why: preserve distinct artwork while moving text into safe zones and measuring contrast on the actual composited backgrounds.
</commit_message>
<xml_diff>
--- a/design/templates/nile-night-royal/template.pptx
+++ b/design/templates/nile-night-royal/template.pptx
@@ -126,7 +126,7 @@
           <p:cNvPr id="9" name="creative_background">
             <a:extLst>
               <a:ext uri="{FF2B5EF4-FFF2-40B4-BE49-F238E27FC236}">
-                <a16:creationId xmlns:a16="http://schemas.microsoft.com/office/drawing/2014/main" id="{4741C023-900F-9F59-F844-A2889F61F264}"/>
+                <a16:creationId xmlns:a16="http://schemas.microsoft.com/office/drawing/2014/main" id="{6FC5AD81-F18D-63C4-AA2F-2EC96A1763A4}"/>
               </a:ext>
             </a:extLst>
           </p:cNvPr>
@@ -290,7 +290,7 @@
             </a:lvl1pPr>
           </a:lstStyle>
           <a:p>
-            <a:fld id="{DA01C8C9-DA9E-4EB0-8756-652B0DE35A87}" type="datetimeFigureOut">
+            <a:fld id="{4E307407-BF02-4185-B795-8EFF67E65125}" type="datetimeFigureOut">
               <a:rPr lang="en-US" smtClean="0"/>
               <a:t>10/3/2026</a:t>
             </a:fld>
@@ -332,7 +332,7 @@
           <a:bodyPr/>
           <a:lstStyle/>
           <a:p>
-            <a:fld id="{E8DEFA18-2CFA-4775-9ECD-212CDF18C33F}" type="slidenum">
+            <a:fld id="{0901BA54-D28A-46F7-BDED-B9CC383D9A66}" type="slidenum">
               <a:rPr lang="en-US" smtClean="0"/>
               <a:t>‹#›</a:t>
             </a:fld>
@@ -343,7 +343,7 @@
     </p:spTree>
     <p:extLst>
       <p:ext uri="{BB962C8B-B14F-4D97-AF65-F5344CB8AC3E}">
-        <p14:creationId xmlns:p14="http://schemas.microsoft.com/office/powerpoint/2010/main" val="1117646341"/>
+        <p14:creationId xmlns:p14="http://schemas.microsoft.com/office/powerpoint/2010/main" val="2320476174"/>
       </p:ext>
     </p:extLst>
   </p:cSld>
@@ -375,7 +375,7 @@
           <p:cNvPr id="7" name="creative_background">
             <a:extLst>
               <a:ext uri="{FF2B5EF4-FFF2-40B4-BE49-F238E27FC236}">
-                <a16:creationId xmlns:a16="http://schemas.microsoft.com/office/drawing/2014/main" id="{6EA3E5FE-923F-EE83-D40E-1F2E40CE7B60}"/>
+                <a16:creationId xmlns:a16="http://schemas.microsoft.com/office/drawing/2014/main" id="{A3670B7A-A777-5CD8-D1AA-522E7A8E9A0E}"/>
               </a:ext>
             </a:extLst>
           </p:cNvPr>
@@ -448,7 +448,7 @@
           <a:bodyPr/>
           <a:lstStyle/>
           <a:p>
-            <a:fld id="{DA01C8C9-DA9E-4EB0-8756-652B0DE35A87}" type="datetimeFigureOut">
+            <a:fld id="{4E307407-BF02-4185-B795-8EFF67E65125}" type="datetimeFigureOut">
               <a:rPr lang="en-US" smtClean="0"/>
               <a:t>10/3/2026</a:t>
             </a:fld>
@@ -490,7 +490,7 @@
           <a:bodyPr/>
           <a:lstStyle/>
           <a:p>
-            <a:fld id="{E8DEFA18-2CFA-4775-9ECD-212CDF18C33F}" type="slidenum">
+            <a:fld id="{0901BA54-D28A-46F7-BDED-B9CC383D9A66}" type="slidenum">
               <a:rPr lang="en-US" smtClean="0"/>
               <a:t>‹#›</a:t>
             </a:fld>
@@ -503,7 +503,7 @@
           <p:cNvPr id="8" name="body">
             <a:extLst>
               <a:ext uri="{FF2B5EF4-FFF2-40B4-BE49-F238E27FC236}">
-                <a16:creationId xmlns:a16="http://schemas.microsoft.com/office/drawing/2014/main" id="{0C0D362A-85AC-9760-5987-585F9BFC031E}"/>
+                <a16:creationId xmlns:a16="http://schemas.microsoft.com/office/drawing/2014/main" id="{B0498B0D-747D-2FD6-5DC3-BDB358B82F87}"/>
               </a:ext>
             </a:extLst>
           </p:cNvPr>
@@ -543,7 +543,7 @@
           <p:cNvPr id="9" name="source">
             <a:extLst>
               <a:ext uri="{FF2B5EF4-FFF2-40B4-BE49-F238E27FC236}">
-                <a16:creationId xmlns:a16="http://schemas.microsoft.com/office/drawing/2014/main" id="{4BEC1DD2-BCCC-E42F-166B-15CD482E9845}"/>
+                <a16:creationId xmlns:a16="http://schemas.microsoft.com/office/drawing/2014/main" id="{EA82058B-A4CE-FC88-5D67-9D9887E2D7AE}"/>
               </a:ext>
             </a:extLst>
           </p:cNvPr>
@@ -598,7 +598,7 @@
     </p:spTree>
     <p:extLst>
       <p:ext uri="{BB962C8B-B14F-4D97-AF65-F5344CB8AC3E}">
-        <p14:creationId xmlns:p14="http://schemas.microsoft.com/office/powerpoint/2010/main" val="1691881707"/>
+        <p14:creationId xmlns:p14="http://schemas.microsoft.com/office/powerpoint/2010/main" val="3495201835"/>
       </p:ext>
     </p:extLst>
   </p:cSld>
@@ -630,7 +630,7 @@
           <p:cNvPr id="7" name="creative_background">
             <a:extLst>
               <a:ext uri="{FF2B5EF4-FFF2-40B4-BE49-F238E27FC236}">
-                <a16:creationId xmlns:a16="http://schemas.microsoft.com/office/drawing/2014/main" id="{B99F5EF7-47B3-781E-595D-20CE4B188E01}"/>
+                <a16:creationId xmlns:a16="http://schemas.microsoft.com/office/drawing/2014/main" id="{97FC5F04-428E-B4DC-FE62-CE47CA77F944}"/>
               </a:ext>
             </a:extLst>
           </p:cNvPr>
@@ -703,7 +703,7 @@
           <a:bodyPr/>
           <a:lstStyle/>
           <a:p>
-            <a:fld id="{DA01C8C9-DA9E-4EB0-8756-652B0DE35A87}" type="datetimeFigureOut">
+            <a:fld id="{4E307407-BF02-4185-B795-8EFF67E65125}" type="datetimeFigureOut">
               <a:rPr lang="en-US" smtClean="0"/>
               <a:t>10/3/2026</a:t>
             </a:fld>
@@ -745,7 +745,7 @@
           <a:bodyPr/>
           <a:lstStyle/>
           <a:p>
-            <a:fld id="{E8DEFA18-2CFA-4775-9ECD-212CDF18C33F}" type="slidenum">
+            <a:fld id="{0901BA54-D28A-46F7-BDED-B9CC383D9A66}" type="slidenum">
               <a:rPr lang="en-US" smtClean="0"/>
               <a:t>‹#›</a:t>
             </a:fld>
@@ -758,7 +758,7 @@
           <p:cNvPr id="8" name="body">
             <a:extLst>
               <a:ext uri="{FF2B5EF4-FFF2-40B4-BE49-F238E27FC236}">
-                <a16:creationId xmlns:a16="http://schemas.microsoft.com/office/drawing/2014/main" id="{37FC45DB-A5E4-D013-CBE4-C19557D6D780}"/>
+                <a16:creationId xmlns:a16="http://schemas.microsoft.com/office/drawing/2014/main" id="{B9B5005F-F78B-7B7A-9209-2BF61244BBAE}"/>
               </a:ext>
             </a:extLst>
           </p:cNvPr>
@@ -801,7 +801,7 @@
     </p:spTree>
     <p:extLst>
       <p:ext uri="{BB962C8B-B14F-4D97-AF65-F5344CB8AC3E}">
-        <p14:creationId xmlns:p14="http://schemas.microsoft.com/office/powerpoint/2010/main" val="2469613844"/>
+        <p14:creationId xmlns:p14="http://schemas.microsoft.com/office/powerpoint/2010/main" val="4233269999"/>
       </p:ext>
     </p:extLst>
   </p:cSld>
@@ -886,7 +886,7 @@
           <p:cNvPr id="6" name="section_number">
             <a:extLst>
               <a:ext uri="{FF2B5EF4-FFF2-40B4-BE49-F238E27FC236}">
-                <a16:creationId xmlns:a16="http://schemas.microsoft.com/office/drawing/2014/main" id="{075647D4-C690-22A0-DD4F-AAC9F1D79461}"/>
+                <a16:creationId xmlns:a16="http://schemas.microsoft.com/office/drawing/2014/main" id="{D9713FB6-F69D-A470-C3F9-C8C6D28F3ABE}"/>
               </a:ext>
             </a:extLst>
           </p:cNvPr>
@@ -939,7 +939,7 @@
           <p:cNvPr id="7" name="subtitle">
             <a:extLst>
               <a:ext uri="{FF2B5EF4-FFF2-40B4-BE49-F238E27FC236}">
-                <a16:creationId xmlns:a16="http://schemas.microsoft.com/office/drawing/2014/main" id="{FE6A4059-14CD-7445-2FF9-DC1A963053F1}"/>
+                <a16:creationId xmlns:a16="http://schemas.microsoft.com/office/drawing/2014/main" id="{C58A2BD0-3B98-D73D-8E63-BA3AC7D059F0}"/>
               </a:ext>
             </a:extLst>
           </p:cNvPr>
@@ -989,7 +989,7 @@
     </p:spTree>
     <p:extLst>
       <p:ext uri="{BB962C8B-B14F-4D97-AF65-F5344CB8AC3E}">
-        <p14:creationId xmlns:p14="http://schemas.microsoft.com/office/powerpoint/2010/main" val="958630272"/>
+        <p14:creationId xmlns:p14="http://schemas.microsoft.com/office/powerpoint/2010/main" val="3976228014"/>
       </p:ext>
     </p:extLst>
   </p:cSld>
@@ -1021,7 +1021,7 @@
           <p:cNvPr id="7" name="creative_background">
             <a:extLst>
               <a:ext uri="{FF2B5EF4-FFF2-40B4-BE49-F238E27FC236}">
-                <a16:creationId xmlns:a16="http://schemas.microsoft.com/office/drawing/2014/main" id="{A4A36D59-CF37-6156-E920-B128DE3F5C3B}"/>
+                <a16:creationId xmlns:a16="http://schemas.microsoft.com/office/drawing/2014/main" id="{8CFCA2AF-BB06-7840-B76C-8D37A7218B46}"/>
               </a:ext>
             </a:extLst>
           </p:cNvPr>
@@ -1094,7 +1094,7 @@
           <a:bodyPr/>
           <a:lstStyle/>
           <a:p>
-            <a:fld id="{DA01C8C9-DA9E-4EB0-8756-652B0DE35A87}" type="datetimeFigureOut">
+            <a:fld id="{4E307407-BF02-4185-B795-8EFF67E65125}" type="datetimeFigureOut">
               <a:rPr lang="en-US" smtClean="0"/>
               <a:t>10/3/2026</a:t>
             </a:fld>
@@ -1136,7 +1136,7 @@
           <a:bodyPr/>
           <a:lstStyle/>
           <a:p>
-            <a:fld id="{E8DEFA18-2CFA-4775-9ECD-212CDF18C33F}" type="slidenum">
+            <a:fld id="{0901BA54-D28A-46F7-BDED-B9CC383D9A66}" type="slidenum">
               <a:rPr lang="en-US" smtClean="0"/>
               <a:t>‹#›</a:t>
             </a:fld>
@@ -1149,7 +1149,7 @@
           <p:cNvPr id="8" name="item_1_title">
             <a:extLst>
               <a:ext uri="{FF2B5EF4-FFF2-40B4-BE49-F238E27FC236}">
-                <a16:creationId xmlns:a16="http://schemas.microsoft.com/office/drawing/2014/main" id="{58E90B4F-D21E-9BCE-76F6-838F154E9EF8}"/>
+                <a16:creationId xmlns:a16="http://schemas.microsoft.com/office/drawing/2014/main" id="{62F8EF3D-7C7D-E0DC-6F6B-72D5D52C0812}"/>
               </a:ext>
             </a:extLst>
           </p:cNvPr>
@@ -1199,7 +1199,7 @@
           <p:cNvPr id="9" name="item_1">
             <a:extLst>
               <a:ext uri="{FF2B5EF4-FFF2-40B4-BE49-F238E27FC236}">
-                <a16:creationId xmlns:a16="http://schemas.microsoft.com/office/drawing/2014/main" id="{C246FBC3-200B-1826-24FA-EF5206352FFC}"/>
+                <a16:creationId xmlns:a16="http://schemas.microsoft.com/office/drawing/2014/main" id="{646C5C20-48CF-EDA4-141F-190D55483F1E}"/>
               </a:ext>
             </a:extLst>
           </p:cNvPr>
@@ -1247,7 +1247,7 @@
           <p:cNvPr id="10" name="item_2_title">
             <a:extLst>
               <a:ext uri="{FF2B5EF4-FFF2-40B4-BE49-F238E27FC236}">
-                <a16:creationId xmlns:a16="http://schemas.microsoft.com/office/drawing/2014/main" id="{DEF41675-89F5-BDAC-2C01-61ACBFF711C9}"/>
+                <a16:creationId xmlns:a16="http://schemas.microsoft.com/office/drawing/2014/main" id="{575BDE51-E07D-456F-F6B6-A813B88648D4}"/>
               </a:ext>
             </a:extLst>
           </p:cNvPr>
@@ -1300,7 +1300,7 @@
           <p:cNvPr id="11" name="item_2">
             <a:extLst>
               <a:ext uri="{FF2B5EF4-FFF2-40B4-BE49-F238E27FC236}">
-                <a16:creationId xmlns:a16="http://schemas.microsoft.com/office/drawing/2014/main" id="{34C1EC16-8B32-D9C5-3491-74433361FF7F}"/>
+                <a16:creationId xmlns:a16="http://schemas.microsoft.com/office/drawing/2014/main" id="{E53E56EE-7BB0-724B-DAF9-DD9ACCDB34CF}"/>
               </a:ext>
             </a:extLst>
           </p:cNvPr>
@@ -1348,7 +1348,7 @@
           <p:cNvPr id="12" name="item_3_title">
             <a:extLst>
               <a:ext uri="{FF2B5EF4-FFF2-40B4-BE49-F238E27FC236}">
-                <a16:creationId xmlns:a16="http://schemas.microsoft.com/office/drawing/2014/main" id="{A7CC0BE1-B3AB-80BC-8231-1B00325DBBFE}"/>
+                <a16:creationId xmlns:a16="http://schemas.microsoft.com/office/drawing/2014/main" id="{311CCDA2-D979-70BD-4D83-5A30D146438D}"/>
               </a:ext>
             </a:extLst>
           </p:cNvPr>
@@ -1401,7 +1401,7 @@
           <p:cNvPr id="13" name="item_3">
             <a:extLst>
               <a:ext uri="{FF2B5EF4-FFF2-40B4-BE49-F238E27FC236}">
-                <a16:creationId xmlns:a16="http://schemas.microsoft.com/office/drawing/2014/main" id="{57DA87B5-41DD-87F0-2307-1ECAE0DEA86B}"/>
+                <a16:creationId xmlns:a16="http://schemas.microsoft.com/office/drawing/2014/main" id="{CED06B9C-20E5-8C70-4100-BB7B5F5C32B3}"/>
               </a:ext>
             </a:extLst>
           </p:cNvPr>
@@ -1449,7 +1449,7 @@
           <p:cNvPr id="14" name="item_4_title">
             <a:extLst>
               <a:ext uri="{FF2B5EF4-FFF2-40B4-BE49-F238E27FC236}">
-                <a16:creationId xmlns:a16="http://schemas.microsoft.com/office/drawing/2014/main" id="{3CD2D3AB-0BBF-5A5C-72A9-50ABDAA08862}"/>
+                <a16:creationId xmlns:a16="http://schemas.microsoft.com/office/drawing/2014/main" id="{18FB863E-BA21-BDFD-E24A-523D51489A5B}"/>
               </a:ext>
             </a:extLst>
           </p:cNvPr>
@@ -1502,7 +1502,7 @@
           <p:cNvPr id="15" name="item_4">
             <a:extLst>
               <a:ext uri="{FF2B5EF4-FFF2-40B4-BE49-F238E27FC236}">
-                <a16:creationId xmlns:a16="http://schemas.microsoft.com/office/drawing/2014/main" id="{31655889-DB0E-CF36-A963-FBAB0E9F2F76}"/>
+                <a16:creationId xmlns:a16="http://schemas.microsoft.com/office/drawing/2014/main" id="{6B837CDC-B868-2475-9DBA-8BC9C525B370}"/>
               </a:ext>
             </a:extLst>
           </p:cNvPr>
@@ -1550,7 +1550,7 @@
           <p:cNvPr id="16" name="source">
             <a:extLst>
               <a:ext uri="{FF2B5EF4-FFF2-40B4-BE49-F238E27FC236}">
-                <a16:creationId xmlns:a16="http://schemas.microsoft.com/office/drawing/2014/main" id="{9D98CCFA-59F5-AB79-EE57-7C3045D6A4AA}"/>
+                <a16:creationId xmlns:a16="http://schemas.microsoft.com/office/drawing/2014/main" id="{0F482EA3-8F5C-6A34-CC54-58FFB721BADF}"/>
               </a:ext>
             </a:extLst>
           </p:cNvPr>
@@ -1605,7 +1605,7 @@
     </p:spTree>
     <p:extLst>
       <p:ext uri="{BB962C8B-B14F-4D97-AF65-F5344CB8AC3E}">
-        <p14:creationId xmlns:p14="http://schemas.microsoft.com/office/powerpoint/2010/main" val="774006495"/>
+        <p14:creationId xmlns:p14="http://schemas.microsoft.com/office/powerpoint/2010/main" val="358217055"/>
       </p:ext>
     </p:extLst>
   </p:cSld>
@@ -1637,7 +1637,7 @@
           <p:cNvPr id="7" name="creative_background">
             <a:extLst>
               <a:ext uri="{FF2B5EF4-FFF2-40B4-BE49-F238E27FC236}">
-                <a16:creationId xmlns:a16="http://schemas.microsoft.com/office/drawing/2014/main" id="{C49F21E1-D7A1-E623-5E2B-3EDE1AD8083A}"/>
+                <a16:creationId xmlns:a16="http://schemas.microsoft.com/office/drawing/2014/main" id="{FFE3E92E-C19D-517B-4AA3-74EDDA7CD96D}"/>
               </a:ext>
             </a:extLst>
           </p:cNvPr>
@@ -1710,7 +1710,7 @@
           <a:bodyPr/>
           <a:lstStyle/>
           <a:p>
-            <a:fld id="{DA01C8C9-DA9E-4EB0-8756-652B0DE35A87}" type="datetimeFigureOut">
+            <a:fld id="{4E307407-BF02-4185-B795-8EFF67E65125}" type="datetimeFigureOut">
               <a:rPr lang="en-US" smtClean="0"/>
               <a:t>10/3/2026</a:t>
             </a:fld>
@@ -1752,7 +1752,7 @@
           <a:bodyPr/>
           <a:lstStyle/>
           <a:p>
-            <a:fld id="{E8DEFA18-2CFA-4775-9ECD-212CDF18C33F}" type="slidenum">
+            <a:fld id="{0901BA54-D28A-46F7-BDED-B9CC383D9A66}" type="slidenum">
               <a:rPr lang="en-US" smtClean="0"/>
               <a:t>‹#›</a:t>
             </a:fld>
@@ -1765,7 +1765,7 @@
           <p:cNvPr id="8" name="body">
             <a:extLst>
               <a:ext uri="{FF2B5EF4-FFF2-40B4-BE49-F238E27FC236}">
-                <a16:creationId xmlns:a16="http://schemas.microsoft.com/office/drawing/2014/main" id="{D099ECA7-7A2A-65D5-5861-2E49BC4363FC}"/>
+                <a16:creationId xmlns:a16="http://schemas.microsoft.com/office/drawing/2014/main" id="{F53390D3-1BE5-C9F4-AEF0-017C4C388FA9}"/>
               </a:ext>
             </a:extLst>
           </p:cNvPr>
@@ -1810,7 +1810,7 @@
           <p:cNvPr id="9" name="source">
             <a:extLst>
               <a:ext uri="{FF2B5EF4-FFF2-40B4-BE49-F238E27FC236}">
-                <a16:creationId xmlns:a16="http://schemas.microsoft.com/office/drawing/2014/main" id="{21304199-DA14-F4EF-B0CE-BB0E6CDBBBFA}"/>
+                <a16:creationId xmlns:a16="http://schemas.microsoft.com/office/drawing/2014/main" id="{BFA968AA-25B9-940E-AE1C-240FCCACDD63}"/>
               </a:ext>
             </a:extLst>
           </p:cNvPr>
@@ -1865,7 +1865,7 @@
     </p:spTree>
     <p:extLst>
       <p:ext uri="{BB962C8B-B14F-4D97-AF65-F5344CB8AC3E}">
-        <p14:creationId xmlns:p14="http://schemas.microsoft.com/office/powerpoint/2010/main" val="3064730035"/>
+        <p14:creationId xmlns:p14="http://schemas.microsoft.com/office/powerpoint/2010/main" val="1068193740"/>
       </p:ext>
     </p:extLst>
   </p:cSld>
@@ -1897,7 +1897,7 @@
           <p:cNvPr id="7" name="creative_background">
             <a:extLst>
               <a:ext uri="{FF2B5EF4-FFF2-40B4-BE49-F238E27FC236}">
-                <a16:creationId xmlns:a16="http://schemas.microsoft.com/office/drawing/2014/main" id="{A01E83CC-6F05-6753-AB9A-126E65C47758}"/>
+                <a16:creationId xmlns:a16="http://schemas.microsoft.com/office/drawing/2014/main" id="{BCC8AC27-1F53-98F7-1FED-0D19DD702C56}"/>
               </a:ext>
             </a:extLst>
           </p:cNvPr>
@@ -1970,7 +1970,7 @@
           <a:bodyPr/>
           <a:lstStyle/>
           <a:p>
-            <a:fld id="{DA01C8C9-DA9E-4EB0-8756-652B0DE35A87}" type="datetimeFigureOut">
+            <a:fld id="{4E307407-BF02-4185-B795-8EFF67E65125}" type="datetimeFigureOut">
               <a:rPr lang="en-US" smtClean="0"/>
               <a:t>10/3/2026</a:t>
             </a:fld>
@@ -2012,7 +2012,7 @@
           <a:bodyPr/>
           <a:lstStyle/>
           <a:p>
-            <a:fld id="{E8DEFA18-2CFA-4775-9ECD-212CDF18C33F}" type="slidenum">
+            <a:fld id="{0901BA54-D28A-46F7-BDED-B9CC383D9A66}" type="slidenum">
               <a:rPr lang="en-US" smtClean="0"/>
               <a:t>‹#›</a:t>
             </a:fld>
@@ -2025,7 +2025,7 @@
           <p:cNvPr id="8" name="item_1_title">
             <a:extLst>
               <a:ext uri="{FF2B5EF4-FFF2-40B4-BE49-F238E27FC236}">
-                <a16:creationId xmlns:a16="http://schemas.microsoft.com/office/drawing/2014/main" id="{85116DF4-01B0-11C7-E5C5-D275F2122F67}"/>
+                <a16:creationId xmlns:a16="http://schemas.microsoft.com/office/drawing/2014/main" id="{4BEE2CCF-5427-4F01-9830-1DB98494847C}"/>
               </a:ext>
             </a:extLst>
           </p:cNvPr>
@@ -2075,7 +2075,7 @@
           <p:cNvPr id="9" name="item_1">
             <a:extLst>
               <a:ext uri="{FF2B5EF4-FFF2-40B4-BE49-F238E27FC236}">
-                <a16:creationId xmlns:a16="http://schemas.microsoft.com/office/drawing/2014/main" id="{64363D87-28C3-6DD0-3E1D-35837472D27C}"/>
+                <a16:creationId xmlns:a16="http://schemas.microsoft.com/office/drawing/2014/main" id="{CAC921B6-6FEB-7E06-411B-02D62A2F71D6}"/>
               </a:ext>
             </a:extLst>
           </p:cNvPr>
@@ -2123,7 +2123,7 @@
           <p:cNvPr id="10" name="item_2_title">
             <a:extLst>
               <a:ext uri="{FF2B5EF4-FFF2-40B4-BE49-F238E27FC236}">
-                <a16:creationId xmlns:a16="http://schemas.microsoft.com/office/drawing/2014/main" id="{0A74D646-724B-A26A-D8BA-C2AC9F5E2EC9}"/>
+                <a16:creationId xmlns:a16="http://schemas.microsoft.com/office/drawing/2014/main" id="{2ADC4F45-AE6E-FFFC-8EE5-79C08B866D2C}"/>
               </a:ext>
             </a:extLst>
           </p:cNvPr>
@@ -2176,7 +2176,7 @@
           <p:cNvPr id="11" name="item_2">
             <a:extLst>
               <a:ext uri="{FF2B5EF4-FFF2-40B4-BE49-F238E27FC236}">
-                <a16:creationId xmlns:a16="http://schemas.microsoft.com/office/drawing/2014/main" id="{57B04A3D-8E3C-4D90-95E2-055CCE0FA812}"/>
+                <a16:creationId xmlns:a16="http://schemas.microsoft.com/office/drawing/2014/main" id="{37FEA3D4-6D7C-9948-6F70-ABF3A11565D6}"/>
               </a:ext>
             </a:extLst>
           </p:cNvPr>
@@ -2224,7 +2224,7 @@
           <p:cNvPr id="12" name="item_3_title">
             <a:extLst>
               <a:ext uri="{FF2B5EF4-FFF2-40B4-BE49-F238E27FC236}">
-                <a16:creationId xmlns:a16="http://schemas.microsoft.com/office/drawing/2014/main" id="{CCFCF97B-8860-F17A-95CF-ECA595E020CB}"/>
+                <a16:creationId xmlns:a16="http://schemas.microsoft.com/office/drawing/2014/main" id="{21DD9452-16A9-FBA9-1B98-F73ED869C4D4}"/>
               </a:ext>
             </a:extLst>
           </p:cNvPr>
@@ -2277,7 +2277,7 @@
           <p:cNvPr id="13" name="item_3">
             <a:extLst>
               <a:ext uri="{FF2B5EF4-FFF2-40B4-BE49-F238E27FC236}">
-                <a16:creationId xmlns:a16="http://schemas.microsoft.com/office/drawing/2014/main" id="{6F892071-B160-0A4F-C6CF-EBC9186CB733}"/>
+                <a16:creationId xmlns:a16="http://schemas.microsoft.com/office/drawing/2014/main" id="{409B9C32-EE1A-D71F-189D-190906DB88A9}"/>
               </a:ext>
             </a:extLst>
           </p:cNvPr>
@@ -2325,7 +2325,7 @@
           <p:cNvPr id="14" name="item_4_title">
             <a:extLst>
               <a:ext uri="{FF2B5EF4-FFF2-40B4-BE49-F238E27FC236}">
-                <a16:creationId xmlns:a16="http://schemas.microsoft.com/office/drawing/2014/main" id="{D74E03CD-C77D-CD81-DB52-74EF51249DEC}"/>
+                <a16:creationId xmlns:a16="http://schemas.microsoft.com/office/drawing/2014/main" id="{73A04BC4-284A-4BA5-9DCB-6E9BBE05BBAE}"/>
               </a:ext>
             </a:extLst>
           </p:cNvPr>
@@ -2378,7 +2378,7 @@
           <p:cNvPr id="15" name="item_4">
             <a:extLst>
               <a:ext uri="{FF2B5EF4-FFF2-40B4-BE49-F238E27FC236}">
-                <a16:creationId xmlns:a16="http://schemas.microsoft.com/office/drawing/2014/main" id="{BB1DFC24-107B-1325-0B70-2025912A68B7}"/>
+                <a16:creationId xmlns:a16="http://schemas.microsoft.com/office/drawing/2014/main" id="{334FEE4C-926B-A9F0-9279-79A097116F81}"/>
               </a:ext>
             </a:extLst>
           </p:cNvPr>
@@ -2426,7 +2426,7 @@
           <p:cNvPr id="16" name="source">
             <a:extLst>
               <a:ext uri="{FF2B5EF4-FFF2-40B4-BE49-F238E27FC236}">
-                <a16:creationId xmlns:a16="http://schemas.microsoft.com/office/drawing/2014/main" id="{4D015382-8AF3-8741-82F8-4AE6C623DA14}"/>
+                <a16:creationId xmlns:a16="http://schemas.microsoft.com/office/drawing/2014/main" id="{0D24A261-0FB6-55AD-AB0B-E1E3D58D185B}"/>
               </a:ext>
             </a:extLst>
           </p:cNvPr>
@@ -2481,7 +2481,7 @@
     </p:spTree>
     <p:extLst>
       <p:ext uri="{BB962C8B-B14F-4D97-AF65-F5344CB8AC3E}">
-        <p14:creationId xmlns:p14="http://schemas.microsoft.com/office/powerpoint/2010/main" val="454835708"/>
+        <p14:creationId xmlns:p14="http://schemas.microsoft.com/office/powerpoint/2010/main" val="2029946104"/>
       </p:ext>
     </p:extLst>
   </p:cSld>
@@ -2513,7 +2513,7 @@
           <p:cNvPr id="7" name="creative_background">
             <a:extLst>
               <a:ext uri="{FF2B5EF4-FFF2-40B4-BE49-F238E27FC236}">
-                <a16:creationId xmlns:a16="http://schemas.microsoft.com/office/drawing/2014/main" id="{686C1FE1-FA48-34AB-25B7-53CE849B9E57}"/>
+                <a16:creationId xmlns:a16="http://schemas.microsoft.com/office/drawing/2014/main" id="{7D312854-A809-9BAE-39AE-6E3E731789CD}"/>
               </a:ext>
             </a:extLst>
           </p:cNvPr>
@@ -2586,7 +2586,7 @@
           <a:bodyPr/>
           <a:lstStyle/>
           <a:p>
-            <a:fld id="{DA01C8C9-DA9E-4EB0-8756-652B0DE35A87}" type="datetimeFigureOut">
+            <a:fld id="{4E307407-BF02-4185-B795-8EFF67E65125}" type="datetimeFigureOut">
               <a:rPr lang="en-US" smtClean="0"/>
               <a:t>10/3/2026</a:t>
             </a:fld>
@@ -2628,7 +2628,7 @@
           <a:bodyPr/>
           <a:lstStyle/>
           <a:p>
-            <a:fld id="{E8DEFA18-2CFA-4775-9ECD-212CDF18C33F}" type="slidenum">
+            <a:fld id="{0901BA54-D28A-46F7-BDED-B9CC383D9A66}" type="slidenum">
               <a:rPr lang="en-US" smtClean="0"/>
               <a:t>‹#›</a:t>
             </a:fld>
@@ -2641,7 +2641,7 @@
           <p:cNvPr id="8" name="body">
             <a:extLst>
               <a:ext uri="{FF2B5EF4-FFF2-40B4-BE49-F238E27FC236}">
-                <a16:creationId xmlns:a16="http://schemas.microsoft.com/office/drawing/2014/main" id="{3457CAEB-29BC-7E3B-465F-DD9FA213D13A}"/>
+                <a16:creationId xmlns:a16="http://schemas.microsoft.com/office/drawing/2014/main" id="{83FBF765-F419-40E3-02F3-915A3DA406C2}"/>
               </a:ext>
             </a:extLst>
           </p:cNvPr>
@@ -2681,7 +2681,7 @@
           <p:cNvPr id="9" name="kpi_value_1">
             <a:extLst>
               <a:ext uri="{FF2B5EF4-FFF2-40B4-BE49-F238E27FC236}">
-                <a16:creationId xmlns:a16="http://schemas.microsoft.com/office/drawing/2014/main" id="{B43C94B2-D7EF-D3CF-91FD-DDCDECADF347}"/>
+                <a16:creationId xmlns:a16="http://schemas.microsoft.com/office/drawing/2014/main" id="{89F49326-AB8B-D890-921D-3698EA28C494}"/>
               </a:ext>
             </a:extLst>
           </p:cNvPr>
@@ -2734,7 +2734,7 @@
           <p:cNvPr id="10" name="kpi_label_1">
             <a:extLst>
               <a:ext uri="{FF2B5EF4-FFF2-40B4-BE49-F238E27FC236}">
-                <a16:creationId xmlns:a16="http://schemas.microsoft.com/office/drawing/2014/main" id="{291189CA-7067-18CB-6810-15BA9F5B4369}"/>
+                <a16:creationId xmlns:a16="http://schemas.microsoft.com/office/drawing/2014/main" id="{55321993-D2BB-8461-2E22-F2F822125DF0}"/>
               </a:ext>
             </a:extLst>
           </p:cNvPr>
@@ -2782,7 +2782,7 @@
           <p:cNvPr id="11" name="source">
             <a:extLst>
               <a:ext uri="{FF2B5EF4-FFF2-40B4-BE49-F238E27FC236}">
-                <a16:creationId xmlns:a16="http://schemas.microsoft.com/office/drawing/2014/main" id="{752F09B4-D25E-E689-5671-051C3FA52E12}"/>
+                <a16:creationId xmlns:a16="http://schemas.microsoft.com/office/drawing/2014/main" id="{42C9B9E8-8462-7B86-E960-2F9A43D52A15}"/>
               </a:ext>
             </a:extLst>
           </p:cNvPr>
@@ -2837,7 +2837,7 @@
     </p:spTree>
     <p:extLst>
       <p:ext uri="{BB962C8B-B14F-4D97-AF65-F5344CB8AC3E}">
-        <p14:creationId xmlns:p14="http://schemas.microsoft.com/office/powerpoint/2010/main" val="1877385611"/>
+        <p14:creationId xmlns:p14="http://schemas.microsoft.com/office/powerpoint/2010/main" val="3104786836"/>
       </p:ext>
     </p:extLst>
   </p:cSld>
@@ -2869,7 +2869,7 @@
           <p:cNvPr id="7" name="creative_background">
             <a:extLst>
               <a:ext uri="{FF2B5EF4-FFF2-40B4-BE49-F238E27FC236}">
-                <a16:creationId xmlns:a16="http://schemas.microsoft.com/office/drawing/2014/main" id="{50EDBC28-6D5F-A4AF-F6D4-090F75AD7370}"/>
+                <a16:creationId xmlns:a16="http://schemas.microsoft.com/office/drawing/2014/main" id="{A0C5D205-6A25-AFFE-E061-3771DF9CF7FD}"/>
               </a:ext>
             </a:extLst>
           </p:cNvPr>
@@ -2942,7 +2942,7 @@
           <a:bodyPr/>
           <a:lstStyle/>
           <a:p>
-            <a:fld id="{DA01C8C9-DA9E-4EB0-8756-652B0DE35A87}" type="datetimeFigureOut">
+            <a:fld id="{4E307407-BF02-4185-B795-8EFF67E65125}" type="datetimeFigureOut">
               <a:rPr lang="en-US" smtClean="0"/>
               <a:t>10/3/2026</a:t>
             </a:fld>
@@ -2984,7 +2984,7 @@
           <a:bodyPr/>
           <a:lstStyle/>
           <a:p>
-            <a:fld id="{E8DEFA18-2CFA-4775-9ECD-212CDF18C33F}" type="slidenum">
+            <a:fld id="{0901BA54-D28A-46F7-BDED-B9CC383D9A66}" type="slidenum">
               <a:rPr lang="en-US" smtClean="0"/>
               <a:t>‹#›</a:t>
             </a:fld>
@@ -2997,7 +2997,7 @@
           <p:cNvPr id="8" name="body">
             <a:extLst>
               <a:ext uri="{FF2B5EF4-FFF2-40B4-BE49-F238E27FC236}">
-                <a16:creationId xmlns:a16="http://schemas.microsoft.com/office/drawing/2014/main" id="{4E92D20B-F70F-43E0-F0E8-6FD2D605C47D}"/>
+                <a16:creationId xmlns:a16="http://schemas.microsoft.com/office/drawing/2014/main" id="{E0B21D16-42C2-62DA-761F-2EEBC42ECFA7}"/>
               </a:ext>
             </a:extLst>
           </p:cNvPr>
@@ -3037,7 +3037,7 @@
           <p:cNvPr id="9" name="kpi_value_1">
             <a:extLst>
               <a:ext uri="{FF2B5EF4-FFF2-40B4-BE49-F238E27FC236}">
-                <a16:creationId xmlns:a16="http://schemas.microsoft.com/office/drawing/2014/main" id="{9EF763DF-5C8F-6009-04D3-1540D12DC25A}"/>
+                <a16:creationId xmlns:a16="http://schemas.microsoft.com/office/drawing/2014/main" id="{06F5E8F5-088C-9CEB-E5F7-FFA868107FE2}"/>
               </a:ext>
             </a:extLst>
           </p:cNvPr>
@@ -3090,7 +3090,7 @@
           <p:cNvPr id="10" name="kpi_label_1">
             <a:extLst>
               <a:ext uri="{FF2B5EF4-FFF2-40B4-BE49-F238E27FC236}">
-                <a16:creationId xmlns:a16="http://schemas.microsoft.com/office/drawing/2014/main" id="{84DD39E5-5F68-1F0B-6A7D-C191E76F0C8D}"/>
+                <a16:creationId xmlns:a16="http://schemas.microsoft.com/office/drawing/2014/main" id="{CC5CC8C9-E321-95F6-8E3D-17514E4EE3C3}"/>
               </a:ext>
             </a:extLst>
           </p:cNvPr>
@@ -3138,7 +3138,7 @@
           <p:cNvPr id="11" name="kpi_value_2">
             <a:extLst>
               <a:ext uri="{FF2B5EF4-FFF2-40B4-BE49-F238E27FC236}">
-                <a16:creationId xmlns:a16="http://schemas.microsoft.com/office/drawing/2014/main" id="{46E0398F-56C2-746F-6D9C-6DEC5BEF1B5A}"/>
+                <a16:creationId xmlns:a16="http://schemas.microsoft.com/office/drawing/2014/main" id="{037C5D12-117F-E485-613F-97AD4E744DE5}"/>
               </a:ext>
             </a:extLst>
           </p:cNvPr>
@@ -3191,7 +3191,7 @@
           <p:cNvPr id="12" name="kpi_label_2">
             <a:extLst>
               <a:ext uri="{FF2B5EF4-FFF2-40B4-BE49-F238E27FC236}">
-                <a16:creationId xmlns:a16="http://schemas.microsoft.com/office/drawing/2014/main" id="{710E8D78-D6A7-5481-C66F-39C768B2C518}"/>
+                <a16:creationId xmlns:a16="http://schemas.microsoft.com/office/drawing/2014/main" id="{A0362166-13CD-B81A-C2C4-13D623509B09}"/>
               </a:ext>
             </a:extLst>
           </p:cNvPr>
@@ -3239,7 +3239,7 @@
           <p:cNvPr id="13" name="kpi_value_3">
             <a:extLst>
               <a:ext uri="{FF2B5EF4-FFF2-40B4-BE49-F238E27FC236}">
-                <a16:creationId xmlns:a16="http://schemas.microsoft.com/office/drawing/2014/main" id="{DA0888FF-8477-5726-7F78-72B2B4F9E81E}"/>
+                <a16:creationId xmlns:a16="http://schemas.microsoft.com/office/drawing/2014/main" id="{41CFE163-DAE4-0562-E4CC-7B42C481E164}"/>
               </a:ext>
             </a:extLst>
           </p:cNvPr>
@@ -3292,7 +3292,7 @@
           <p:cNvPr id="14" name="kpi_label_3">
             <a:extLst>
               <a:ext uri="{FF2B5EF4-FFF2-40B4-BE49-F238E27FC236}">
-                <a16:creationId xmlns:a16="http://schemas.microsoft.com/office/drawing/2014/main" id="{D1CD755A-D9D2-F897-D33D-9AC22245807E}"/>
+                <a16:creationId xmlns:a16="http://schemas.microsoft.com/office/drawing/2014/main" id="{5152F2F3-8D60-A44C-A5F4-7FB3D239AC80}"/>
               </a:ext>
             </a:extLst>
           </p:cNvPr>
@@ -3340,7 +3340,7 @@
           <p:cNvPr id="15" name="kpi_value_4">
             <a:extLst>
               <a:ext uri="{FF2B5EF4-FFF2-40B4-BE49-F238E27FC236}">
-                <a16:creationId xmlns:a16="http://schemas.microsoft.com/office/drawing/2014/main" id="{22A410DC-9369-E4BE-FB46-013FDA206D91}"/>
+                <a16:creationId xmlns:a16="http://schemas.microsoft.com/office/drawing/2014/main" id="{0E184570-4A44-612E-5466-B1080CC04075}"/>
               </a:ext>
             </a:extLst>
           </p:cNvPr>
@@ -3393,7 +3393,7 @@
           <p:cNvPr id="16" name="kpi_label_4">
             <a:extLst>
               <a:ext uri="{FF2B5EF4-FFF2-40B4-BE49-F238E27FC236}">
-                <a16:creationId xmlns:a16="http://schemas.microsoft.com/office/drawing/2014/main" id="{412FA378-0901-1105-71F1-9749CD12CEBB}"/>
+                <a16:creationId xmlns:a16="http://schemas.microsoft.com/office/drawing/2014/main" id="{C6DCC0EE-EDD2-9875-7906-E26F9BECD9D9}"/>
               </a:ext>
             </a:extLst>
           </p:cNvPr>
@@ -3441,7 +3441,7 @@
           <p:cNvPr id="17" name="source">
             <a:extLst>
               <a:ext uri="{FF2B5EF4-FFF2-40B4-BE49-F238E27FC236}">
-                <a16:creationId xmlns:a16="http://schemas.microsoft.com/office/drawing/2014/main" id="{388E5FDF-461A-F7AD-E8E1-01664648F9D5}"/>
+                <a16:creationId xmlns:a16="http://schemas.microsoft.com/office/drawing/2014/main" id="{956DF674-243E-74E6-C346-A6633C34174F}"/>
               </a:ext>
             </a:extLst>
           </p:cNvPr>
@@ -3496,7 +3496,7 @@
     </p:spTree>
     <p:extLst>
       <p:ext uri="{BB962C8B-B14F-4D97-AF65-F5344CB8AC3E}">
-        <p14:creationId xmlns:p14="http://schemas.microsoft.com/office/powerpoint/2010/main" val="957621649"/>
+        <p14:creationId xmlns:p14="http://schemas.microsoft.com/office/powerpoint/2010/main" val="243844207"/>
       </p:ext>
     </p:extLst>
   </p:cSld>
@@ -3528,7 +3528,7 @@
           <p:cNvPr id="7" name="creative_background">
             <a:extLst>
               <a:ext uri="{FF2B5EF4-FFF2-40B4-BE49-F238E27FC236}">
-                <a16:creationId xmlns:a16="http://schemas.microsoft.com/office/drawing/2014/main" id="{B7C387FC-3E57-0251-45E9-501A0B9A066E}"/>
+                <a16:creationId xmlns:a16="http://schemas.microsoft.com/office/drawing/2014/main" id="{9ABF2D95-D594-A95E-8E2A-8C608DAA877C}"/>
               </a:ext>
             </a:extLst>
           </p:cNvPr>
@@ -3601,7 +3601,7 @@
           <a:bodyPr/>
           <a:lstStyle/>
           <a:p>
-            <a:fld id="{DA01C8C9-DA9E-4EB0-8756-652B0DE35A87}" type="datetimeFigureOut">
+            <a:fld id="{4E307407-BF02-4185-B795-8EFF67E65125}" type="datetimeFigureOut">
               <a:rPr lang="en-US" smtClean="0"/>
               <a:t>10/3/2026</a:t>
             </a:fld>
@@ -3643,7 +3643,7 @@
           <a:bodyPr/>
           <a:lstStyle/>
           <a:p>
-            <a:fld id="{E8DEFA18-2CFA-4775-9ECD-212CDF18C33F}" type="slidenum">
+            <a:fld id="{0901BA54-D28A-46F7-BDED-B9CC383D9A66}" type="slidenum">
               <a:rPr lang="en-US" smtClean="0"/>
               <a:t>‹#›</a:t>
             </a:fld>
@@ -3656,7 +3656,7 @@
           <p:cNvPr id="8" name="body">
             <a:extLst>
               <a:ext uri="{FF2B5EF4-FFF2-40B4-BE49-F238E27FC236}">
-                <a16:creationId xmlns:a16="http://schemas.microsoft.com/office/drawing/2014/main" id="{C986CDCB-A54A-CD3B-9804-3DBDCEEBEAE9}"/>
+                <a16:creationId xmlns:a16="http://schemas.microsoft.com/office/drawing/2014/main" id="{AAF4C6F6-F21D-51EE-7637-D152A6298607}"/>
               </a:ext>
             </a:extLst>
           </p:cNvPr>
@@ -3696,7 +3696,7 @@
           <p:cNvPr id="9" name="kpi_value_1">
             <a:extLst>
               <a:ext uri="{FF2B5EF4-FFF2-40B4-BE49-F238E27FC236}">
-                <a16:creationId xmlns:a16="http://schemas.microsoft.com/office/drawing/2014/main" id="{1F01DB15-F333-4EDF-98F4-BBED1BDA10F3}"/>
+                <a16:creationId xmlns:a16="http://schemas.microsoft.com/office/drawing/2014/main" id="{684481E5-EC58-D9ED-9E8D-E410C6FB7729}"/>
               </a:ext>
             </a:extLst>
           </p:cNvPr>
@@ -3749,7 +3749,7 @@
           <p:cNvPr id="10" name="kpi_label_1">
             <a:extLst>
               <a:ext uri="{FF2B5EF4-FFF2-40B4-BE49-F238E27FC236}">
-                <a16:creationId xmlns:a16="http://schemas.microsoft.com/office/drawing/2014/main" id="{224E7937-160E-0360-2C5C-9A7928614CF6}"/>
+                <a16:creationId xmlns:a16="http://schemas.microsoft.com/office/drawing/2014/main" id="{7AB4C8C1-1479-55E0-DC85-0F0FA4A7EEBB}"/>
               </a:ext>
             </a:extLst>
           </p:cNvPr>
@@ -3797,7 +3797,7 @@
           <p:cNvPr id="11" name="kpi_value_2">
             <a:extLst>
               <a:ext uri="{FF2B5EF4-FFF2-40B4-BE49-F238E27FC236}">
-                <a16:creationId xmlns:a16="http://schemas.microsoft.com/office/drawing/2014/main" id="{3AB03CB9-030E-3CAD-C92C-AFF60C234F0D}"/>
+                <a16:creationId xmlns:a16="http://schemas.microsoft.com/office/drawing/2014/main" id="{CA9133D8-F030-02CD-A7EE-13560B34C9BC}"/>
               </a:ext>
             </a:extLst>
           </p:cNvPr>
@@ -3850,7 +3850,7 @@
           <p:cNvPr id="12" name="kpi_label_2">
             <a:extLst>
               <a:ext uri="{FF2B5EF4-FFF2-40B4-BE49-F238E27FC236}">
-                <a16:creationId xmlns:a16="http://schemas.microsoft.com/office/drawing/2014/main" id="{B50A5F42-A4FB-51DB-FA15-8366BD257DC6}"/>
+                <a16:creationId xmlns:a16="http://schemas.microsoft.com/office/drawing/2014/main" id="{32132DB5-F5D5-4953-EC6F-D6905D07403D}"/>
               </a:ext>
             </a:extLst>
           </p:cNvPr>
@@ -3898,7 +3898,7 @@
           <p:cNvPr id="13" name="source">
             <a:extLst>
               <a:ext uri="{FF2B5EF4-FFF2-40B4-BE49-F238E27FC236}">
-                <a16:creationId xmlns:a16="http://schemas.microsoft.com/office/drawing/2014/main" id="{2A413918-F8EB-1085-FBAE-87AA0F3762D4}"/>
+                <a16:creationId xmlns:a16="http://schemas.microsoft.com/office/drawing/2014/main" id="{E7B9A49B-C9D5-BD1B-5B9C-6F505503A9F4}"/>
               </a:ext>
             </a:extLst>
           </p:cNvPr>
@@ -3953,7 +3953,7 @@
     </p:spTree>
     <p:extLst>
       <p:ext uri="{BB962C8B-B14F-4D97-AF65-F5344CB8AC3E}">
-        <p14:creationId xmlns:p14="http://schemas.microsoft.com/office/powerpoint/2010/main" val="835157884"/>
+        <p14:creationId xmlns:p14="http://schemas.microsoft.com/office/powerpoint/2010/main" val="299766994"/>
       </p:ext>
     </p:extLst>
   </p:cSld>
@@ -3985,7 +3985,7 @@
           <p:cNvPr id="7" name="creative_background">
             <a:extLst>
               <a:ext uri="{FF2B5EF4-FFF2-40B4-BE49-F238E27FC236}">
-                <a16:creationId xmlns:a16="http://schemas.microsoft.com/office/drawing/2014/main" id="{A1B15AFA-6090-A03A-75A3-1E3605612EE4}"/>
+                <a16:creationId xmlns:a16="http://schemas.microsoft.com/office/drawing/2014/main" id="{17FE29A4-5612-0C45-109E-301FF5D90047}"/>
               </a:ext>
             </a:extLst>
           </p:cNvPr>
@@ -4058,7 +4058,7 @@
           <a:bodyPr/>
           <a:lstStyle/>
           <a:p>
-            <a:fld id="{DA01C8C9-DA9E-4EB0-8756-652B0DE35A87}" type="datetimeFigureOut">
+            <a:fld id="{4E307407-BF02-4185-B795-8EFF67E65125}" type="datetimeFigureOut">
               <a:rPr lang="en-US" smtClean="0"/>
               <a:t>10/3/2026</a:t>
             </a:fld>
@@ -4100,7 +4100,7 @@
           <a:bodyPr/>
           <a:lstStyle/>
           <a:p>
-            <a:fld id="{E8DEFA18-2CFA-4775-9ECD-212CDF18C33F}" type="slidenum">
+            <a:fld id="{0901BA54-D28A-46F7-BDED-B9CC383D9A66}" type="slidenum">
               <a:rPr lang="en-US" smtClean="0"/>
               <a:t>‹#›</a:t>
             </a:fld>
@@ -4113,7 +4113,7 @@
           <p:cNvPr id="8" name="body">
             <a:extLst>
               <a:ext uri="{FF2B5EF4-FFF2-40B4-BE49-F238E27FC236}">
-                <a16:creationId xmlns:a16="http://schemas.microsoft.com/office/drawing/2014/main" id="{3E420E19-7D2C-B71D-5ECB-2408DFCADE56}"/>
+                <a16:creationId xmlns:a16="http://schemas.microsoft.com/office/drawing/2014/main" id="{6382EEC5-81B1-FA99-D189-633E501D3E16}"/>
               </a:ext>
             </a:extLst>
           </p:cNvPr>
@@ -4153,7 +4153,7 @@
           <p:cNvPr id="9" name="kpi_value_1">
             <a:extLst>
               <a:ext uri="{FF2B5EF4-FFF2-40B4-BE49-F238E27FC236}">
-                <a16:creationId xmlns:a16="http://schemas.microsoft.com/office/drawing/2014/main" id="{4DF780E0-C7B4-9791-7150-2A991910D3F5}"/>
+                <a16:creationId xmlns:a16="http://schemas.microsoft.com/office/drawing/2014/main" id="{1BDDC731-EB90-D757-1D3F-F8EF7DFD0BC4}"/>
               </a:ext>
             </a:extLst>
           </p:cNvPr>
@@ -4206,7 +4206,7 @@
           <p:cNvPr id="10" name="kpi_label_1">
             <a:extLst>
               <a:ext uri="{FF2B5EF4-FFF2-40B4-BE49-F238E27FC236}">
-                <a16:creationId xmlns:a16="http://schemas.microsoft.com/office/drawing/2014/main" id="{559FDBE1-F5F2-A9A7-B1EC-3E5FDAACE8B6}"/>
+                <a16:creationId xmlns:a16="http://schemas.microsoft.com/office/drawing/2014/main" id="{C5FB37B5-9C4D-A6F1-98C1-4B62078681A3}"/>
               </a:ext>
             </a:extLst>
           </p:cNvPr>
@@ -4254,7 +4254,7 @@
           <p:cNvPr id="11" name="kpi_value_2">
             <a:extLst>
               <a:ext uri="{FF2B5EF4-FFF2-40B4-BE49-F238E27FC236}">
-                <a16:creationId xmlns:a16="http://schemas.microsoft.com/office/drawing/2014/main" id="{1BA654FD-2B6E-97C7-4792-156BD4342BB5}"/>
+                <a16:creationId xmlns:a16="http://schemas.microsoft.com/office/drawing/2014/main" id="{3C2AF1C1-BC75-B824-CC6B-EE46C3C340A9}"/>
               </a:ext>
             </a:extLst>
           </p:cNvPr>
@@ -4307,7 +4307,7 @@
           <p:cNvPr id="12" name="kpi_label_2">
             <a:extLst>
               <a:ext uri="{FF2B5EF4-FFF2-40B4-BE49-F238E27FC236}">
-                <a16:creationId xmlns:a16="http://schemas.microsoft.com/office/drawing/2014/main" id="{1CAE2067-3BEE-58EC-449D-E5E81C550C54}"/>
+                <a16:creationId xmlns:a16="http://schemas.microsoft.com/office/drawing/2014/main" id="{C97C9504-286D-BFD2-B0E1-62DBDF8A9843}"/>
               </a:ext>
             </a:extLst>
           </p:cNvPr>
@@ -4355,7 +4355,7 @@
           <p:cNvPr id="13" name="kpi_value_3">
             <a:extLst>
               <a:ext uri="{FF2B5EF4-FFF2-40B4-BE49-F238E27FC236}">
-                <a16:creationId xmlns:a16="http://schemas.microsoft.com/office/drawing/2014/main" id="{5980362B-A899-3FD9-EC2B-93DB279A5D0B}"/>
+                <a16:creationId xmlns:a16="http://schemas.microsoft.com/office/drawing/2014/main" id="{41A84025-9EA3-EBD4-799A-A19F62A87174}"/>
               </a:ext>
             </a:extLst>
           </p:cNvPr>
@@ -4408,7 +4408,7 @@
           <p:cNvPr id="14" name="kpi_label_3">
             <a:extLst>
               <a:ext uri="{FF2B5EF4-FFF2-40B4-BE49-F238E27FC236}">
-                <a16:creationId xmlns:a16="http://schemas.microsoft.com/office/drawing/2014/main" id="{F73F0C0E-1308-D295-044F-BFEA5AD6D905}"/>
+                <a16:creationId xmlns:a16="http://schemas.microsoft.com/office/drawing/2014/main" id="{9E62CD7C-0E47-3118-3FBF-B3505C3DB6D3}"/>
               </a:ext>
             </a:extLst>
           </p:cNvPr>
@@ -4456,7 +4456,7 @@
           <p:cNvPr id="15" name="kpi_value_4">
             <a:extLst>
               <a:ext uri="{FF2B5EF4-FFF2-40B4-BE49-F238E27FC236}">
-                <a16:creationId xmlns:a16="http://schemas.microsoft.com/office/drawing/2014/main" id="{E5FE864A-DBB8-F76C-90B5-9DDAABDC98C1}"/>
+                <a16:creationId xmlns:a16="http://schemas.microsoft.com/office/drawing/2014/main" id="{5DEB4EF7-0B03-2901-EE6A-D874C0A94712}"/>
               </a:ext>
             </a:extLst>
           </p:cNvPr>
@@ -4509,7 +4509,7 @@
           <p:cNvPr id="16" name="kpi_label_4">
             <a:extLst>
               <a:ext uri="{FF2B5EF4-FFF2-40B4-BE49-F238E27FC236}">
-                <a16:creationId xmlns:a16="http://schemas.microsoft.com/office/drawing/2014/main" id="{3F20D6F6-30F3-25D2-549B-A7BAF202B915}"/>
+                <a16:creationId xmlns:a16="http://schemas.microsoft.com/office/drawing/2014/main" id="{27F2B364-03AC-31A6-0C69-BE07ADB9A8B2}"/>
               </a:ext>
             </a:extLst>
           </p:cNvPr>
@@ -4557,7 +4557,7 @@
           <p:cNvPr id="17" name="source">
             <a:extLst>
               <a:ext uri="{FF2B5EF4-FFF2-40B4-BE49-F238E27FC236}">
-                <a16:creationId xmlns:a16="http://schemas.microsoft.com/office/drawing/2014/main" id="{F0E4E4C7-5477-4441-C116-A3DF95D9417E}"/>
+                <a16:creationId xmlns:a16="http://schemas.microsoft.com/office/drawing/2014/main" id="{5FCC0DDD-9A3F-9F5F-69D1-0BB1E006C7CC}"/>
               </a:ext>
             </a:extLst>
           </p:cNvPr>
@@ -4612,7 +4612,7 @@
     </p:spTree>
     <p:extLst>
       <p:ext uri="{BB962C8B-B14F-4D97-AF65-F5344CB8AC3E}">
-        <p14:creationId xmlns:p14="http://schemas.microsoft.com/office/powerpoint/2010/main" val="2874668706"/>
+        <p14:creationId xmlns:p14="http://schemas.microsoft.com/office/powerpoint/2010/main" val="3512553428"/>
       </p:ext>
     </p:extLst>
   </p:cSld>
@@ -4644,7 +4644,7 @@
           <p:cNvPr id="7" name="creative_background">
             <a:extLst>
               <a:ext uri="{FF2B5EF4-FFF2-40B4-BE49-F238E27FC236}">
-                <a16:creationId xmlns:a16="http://schemas.microsoft.com/office/drawing/2014/main" id="{3DEC32B1-E879-7403-2BA4-2BD887DBA286}"/>
+                <a16:creationId xmlns:a16="http://schemas.microsoft.com/office/drawing/2014/main" id="{585EC484-95AA-2563-A05B-353E14A378CB}"/>
               </a:ext>
             </a:extLst>
           </p:cNvPr>
@@ -4717,7 +4717,7 @@
           <a:bodyPr/>
           <a:lstStyle/>
           <a:p>
-            <a:fld id="{DA01C8C9-DA9E-4EB0-8756-652B0DE35A87}" type="datetimeFigureOut">
+            <a:fld id="{4E307407-BF02-4185-B795-8EFF67E65125}" type="datetimeFigureOut">
               <a:rPr lang="en-US" smtClean="0"/>
               <a:t>10/3/2026</a:t>
             </a:fld>
@@ -4759,7 +4759,7 @@
           <a:bodyPr/>
           <a:lstStyle/>
           <a:p>
-            <a:fld id="{E8DEFA18-2CFA-4775-9ECD-212CDF18C33F}" type="slidenum">
+            <a:fld id="{0901BA54-D28A-46F7-BDED-B9CC383D9A66}" type="slidenum">
               <a:rPr lang="en-US" smtClean="0"/>
               <a:t>‹#›</a:t>
             </a:fld>
@@ -4772,7 +4772,7 @@
           <p:cNvPr id="8" name="item_1_title">
             <a:extLst>
               <a:ext uri="{FF2B5EF4-FFF2-40B4-BE49-F238E27FC236}">
-                <a16:creationId xmlns:a16="http://schemas.microsoft.com/office/drawing/2014/main" id="{6786CFE1-1BAA-D8D9-509D-FA9C1211A897}"/>
+                <a16:creationId xmlns:a16="http://schemas.microsoft.com/office/drawing/2014/main" id="{AAD7D69A-D079-BA3A-AFAE-F2FA055DC2B3}"/>
               </a:ext>
             </a:extLst>
           </p:cNvPr>
@@ -4822,7 +4822,7 @@
           <p:cNvPr id="9" name="item_1">
             <a:extLst>
               <a:ext uri="{FF2B5EF4-FFF2-40B4-BE49-F238E27FC236}">
-                <a16:creationId xmlns:a16="http://schemas.microsoft.com/office/drawing/2014/main" id="{FF004CCC-5B61-5627-F4AC-0E5E5BBDABCB}"/>
+                <a16:creationId xmlns:a16="http://schemas.microsoft.com/office/drawing/2014/main" id="{0A7C78E7-E219-57B2-D120-9340A5490E59}"/>
               </a:ext>
             </a:extLst>
           </p:cNvPr>
@@ -4870,7 +4870,7 @@
           <p:cNvPr id="10" name="item_2_title">
             <a:extLst>
               <a:ext uri="{FF2B5EF4-FFF2-40B4-BE49-F238E27FC236}">
-                <a16:creationId xmlns:a16="http://schemas.microsoft.com/office/drawing/2014/main" id="{6C3E38E2-0FEE-9C8A-CBCC-8B56A4BB1FC5}"/>
+                <a16:creationId xmlns:a16="http://schemas.microsoft.com/office/drawing/2014/main" id="{AA99676A-4687-7BBB-3830-13775B92D4FA}"/>
               </a:ext>
             </a:extLst>
           </p:cNvPr>
@@ -4923,7 +4923,7 @@
           <p:cNvPr id="11" name="item_2">
             <a:extLst>
               <a:ext uri="{FF2B5EF4-FFF2-40B4-BE49-F238E27FC236}">
-                <a16:creationId xmlns:a16="http://schemas.microsoft.com/office/drawing/2014/main" id="{058D0343-6598-3677-B87E-7CFF79EB138A}"/>
+                <a16:creationId xmlns:a16="http://schemas.microsoft.com/office/drawing/2014/main" id="{1F8EBE13-13D0-E485-A139-50BFAECD62D3}"/>
               </a:ext>
             </a:extLst>
           </p:cNvPr>
@@ -4971,7 +4971,7 @@
           <p:cNvPr id="12" name="item_3_title">
             <a:extLst>
               <a:ext uri="{FF2B5EF4-FFF2-40B4-BE49-F238E27FC236}">
-                <a16:creationId xmlns:a16="http://schemas.microsoft.com/office/drawing/2014/main" id="{7E4365C0-CF49-FA48-E8B1-CE04CE507244}"/>
+                <a16:creationId xmlns:a16="http://schemas.microsoft.com/office/drawing/2014/main" id="{4E2E4A86-AF63-92BA-09A3-BD994DF81470}"/>
               </a:ext>
             </a:extLst>
           </p:cNvPr>
@@ -5024,7 +5024,7 @@
           <p:cNvPr id="13" name="item_3">
             <a:extLst>
               <a:ext uri="{FF2B5EF4-FFF2-40B4-BE49-F238E27FC236}">
-                <a16:creationId xmlns:a16="http://schemas.microsoft.com/office/drawing/2014/main" id="{F5797B5E-48D4-B9F3-544A-4C18CAC26A89}"/>
+                <a16:creationId xmlns:a16="http://schemas.microsoft.com/office/drawing/2014/main" id="{564DC59F-33B2-6FE0-F6B4-86CC1E9CD7C7}"/>
               </a:ext>
             </a:extLst>
           </p:cNvPr>
@@ -5072,7 +5072,7 @@
           <p:cNvPr id="14" name="item_4_title">
             <a:extLst>
               <a:ext uri="{FF2B5EF4-FFF2-40B4-BE49-F238E27FC236}">
-                <a16:creationId xmlns:a16="http://schemas.microsoft.com/office/drawing/2014/main" id="{3F7E7FE1-AE70-2B94-057F-0F10B5C9CFE3}"/>
+                <a16:creationId xmlns:a16="http://schemas.microsoft.com/office/drawing/2014/main" id="{B53EC837-39E8-4A01-6C28-C2C0FB45B9B5}"/>
               </a:ext>
             </a:extLst>
           </p:cNvPr>
@@ -5125,7 +5125,7 @@
           <p:cNvPr id="15" name="item_4">
             <a:extLst>
               <a:ext uri="{FF2B5EF4-FFF2-40B4-BE49-F238E27FC236}">
-                <a16:creationId xmlns:a16="http://schemas.microsoft.com/office/drawing/2014/main" id="{D6B995AB-B9FE-ACD5-6745-F7409ADFA76C}"/>
+                <a16:creationId xmlns:a16="http://schemas.microsoft.com/office/drawing/2014/main" id="{C558CC34-A5CB-48E9-EC61-0262A29F8CD9}"/>
               </a:ext>
             </a:extLst>
           </p:cNvPr>
@@ -5173,7 +5173,7 @@
           <p:cNvPr id="16" name="source">
             <a:extLst>
               <a:ext uri="{FF2B5EF4-FFF2-40B4-BE49-F238E27FC236}">
-                <a16:creationId xmlns:a16="http://schemas.microsoft.com/office/drawing/2014/main" id="{82ABA275-8424-7D8A-4B23-F9EBD76B4621}"/>
+                <a16:creationId xmlns:a16="http://schemas.microsoft.com/office/drawing/2014/main" id="{264D31B8-2AB7-C1E7-C92F-1CBBE385EE0B}"/>
               </a:ext>
             </a:extLst>
           </p:cNvPr>
@@ -5228,7 +5228,7 @@
     </p:spTree>
     <p:extLst>
       <p:ext uri="{BB962C8B-B14F-4D97-AF65-F5344CB8AC3E}">
-        <p14:creationId xmlns:p14="http://schemas.microsoft.com/office/powerpoint/2010/main" val="1832383298"/>
+        <p14:creationId xmlns:p14="http://schemas.microsoft.com/office/powerpoint/2010/main" val="2338530930"/>
       </p:ext>
     </p:extLst>
   </p:cSld>
@@ -5260,7 +5260,7 @@
           <p:cNvPr id="7" name="creative_background">
             <a:extLst>
               <a:ext uri="{FF2B5EF4-FFF2-40B4-BE49-F238E27FC236}">
-                <a16:creationId xmlns:a16="http://schemas.microsoft.com/office/drawing/2014/main" id="{E46A53C9-0FB8-E1A2-4FB5-2C47FFDBD641}"/>
+                <a16:creationId xmlns:a16="http://schemas.microsoft.com/office/drawing/2014/main" id="{598D95E9-D1F9-B9A1-3914-434714172F21}"/>
               </a:ext>
             </a:extLst>
           </p:cNvPr>
@@ -5333,7 +5333,7 @@
           <a:bodyPr/>
           <a:lstStyle/>
           <a:p>
-            <a:fld id="{DA01C8C9-DA9E-4EB0-8756-652B0DE35A87}" type="datetimeFigureOut">
+            <a:fld id="{4E307407-BF02-4185-B795-8EFF67E65125}" type="datetimeFigureOut">
               <a:rPr lang="en-US" smtClean="0"/>
               <a:t>10/3/2026</a:t>
             </a:fld>
@@ -5375,7 +5375,7 @@
           <a:bodyPr/>
           <a:lstStyle/>
           <a:p>
-            <a:fld id="{E8DEFA18-2CFA-4775-9ECD-212CDF18C33F}" type="slidenum">
+            <a:fld id="{0901BA54-D28A-46F7-BDED-B9CC383D9A66}" type="slidenum">
               <a:rPr lang="en-US" smtClean="0"/>
               <a:t>‹#›</a:t>
             </a:fld>
@@ -5388,7 +5388,7 @@
           <p:cNvPr id="8" name="marker_1">
             <a:extLst>
               <a:ext uri="{FF2B5EF4-FFF2-40B4-BE49-F238E27FC236}">
-                <a16:creationId xmlns:a16="http://schemas.microsoft.com/office/drawing/2014/main" id="{EB650913-3C82-BB00-30D6-E0D5465A433D}"/>
+                <a16:creationId xmlns:a16="http://schemas.microsoft.com/office/drawing/2014/main" id="{4FE0AAFE-A8D2-91D6-50FF-35A4F7AA0FC3}"/>
               </a:ext>
             </a:extLst>
           </p:cNvPr>
@@ -5444,7 +5444,7 @@
           <p:cNvPr id="9" name="item_1_title">
             <a:extLst>
               <a:ext uri="{FF2B5EF4-FFF2-40B4-BE49-F238E27FC236}">
-                <a16:creationId xmlns:a16="http://schemas.microsoft.com/office/drawing/2014/main" id="{DC70FA01-01DF-283B-2CD7-FB35A320D839}"/>
+                <a16:creationId xmlns:a16="http://schemas.microsoft.com/office/drawing/2014/main" id="{9E2753E9-77F0-F3C1-B181-7E8490D98BA4}"/>
               </a:ext>
             </a:extLst>
           </p:cNvPr>
@@ -5497,7 +5497,7 @@
           <p:cNvPr id="10" name="item_1">
             <a:extLst>
               <a:ext uri="{FF2B5EF4-FFF2-40B4-BE49-F238E27FC236}">
-                <a16:creationId xmlns:a16="http://schemas.microsoft.com/office/drawing/2014/main" id="{7FC2C681-C32F-64CC-84B5-5EE8F03A5168}"/>
+                <a16:creationId xmlns:a16="http://schemas.microsoft.com/office/drawing/2014/main" id="{D40C9FA3-F7B1-B235-AB80-6CE2AA64DAD0}"/>
               </a:ext>
             </a:extLst>
           </p:cNvPr>
@@ -5545,7 +5545,7 @@
           <p:cNvPr id="11" name="marker_2">
             <a:extLst>
               <a:ext uri="{FF2B5EF4-FFF2-40B4-BE49-F238E27FC236}">
-                <a16:creationId xmlns:a16="http://schemas.microsoft.com/office/drawing/2014/main" id="{CA9A505E-605B-3EF7-1E09-E95875B30E6B}"/>
+                <a16:creationId xmlns:a16="http://schemas.microsoft.com/office/drawing/2014/main" id="{F5BC0D81-AF7E-FA63-CB51-12CF7FC7220F}"/>
               </a:ext>
             </a:extLst>
           </p:cNvPr>
@@ -5601,7 +5601,7 @@
           <p:cNvPr id="12" name="item_2_title">
             <a:extLst>
               <a:ext uri="{FF2B5EF4-FFF2-40B4-BE49-F238E27FC236}">
-                <a16:creationId xmlns:a16="http://schemas.microsoft.com/office/drawing/2014/main" id="{B100486C-CBA3-CE6F-6C82-D2C98C71F7EA}"/>
+                <a16:creationId xmlns:a16="http://schemas.microsoft.com/office/drawing/2014/main" id="{23EFCB5D-53AF-7D87-1C22-EE27FF35974D}"/>
               </a:ext>
             </a:extLst>
           </p:cNvPr>
@@ -5654,7 +5654,7 @@
           <p:cNvPr id="13" name="item_2">
             <a:extLst>
               <a:ext uri="{FF2B5EF4-FFF2-40B4-BE49-F238E27FC236}">
-                <a16:creationId xmlns:a16="http://schemas.microsoft.com/office/drawing/2014/main" id="{BC1A4323-1669-B494-15E0-3302B5339404}"/>
+                <a16:creationId xmlns:a16="http://schemas.microsoft.com/office/drawing/2014/main" id="{08A292BE-6CB3-330B-AC53-1CFCBC5FE6AB}"/>
               </a:ext>
             </a:extLst>
           </p:cNvPr>
@@ -5702,7 +5702,7 @@
           <p:cNvPr id="14" name="source">
             <a:extLst>
               <a:ext uri="{FF2B5EF4-FFF2-40B4-BE49-F238E27FC236}">
-                <a16:creationId xmlns:a16="http://schemas.microsoft.com/office/drawing/2014/main" id="{7AEE6E46-588D-9A1A-AFA4-D9CAA6D26620}"/>
+                <a16:creationId xmlns:a16="http://schemas.microsoft.com/office/drawing/2014/main" id="{556A7F21-6DFB-F144-1368-B0DECCA49EAD}"/>
               </a:ext>
             </a:extLst>
           </p:cNvPr>
@@ -5757,7 +5757,7 @@
     </p:spTree>
     <p:extLst>
       <p:ext uri="{BB962C8B-B14F-4D97-AF65-F5344CB8AC3E}">
-        <p14:creationId xmlns:p14="http://schemas.microsoft.com/office/powerpoint/2010/main" val="3656988268"/>
+        <p14:creationId xmlns:p14="http://schemas.microsoft.com/office/powerpoint/2010/main" val="263525826"/>
       </p:ext>
     </p:extLst>
   </p:cSld>
@@ -5789,7 +5789,7 @@
           <p:cNvPr id="7" name="creative_background">
             <a:extLst>
               <a:ext uri="{FF2B5EF4-FFF2-40B4-BE49-F238E27FC236}">
-                <a16:creationId xmlns:a16="http://schemas.microsoft.com/office/drawing/2014/main" id="{5635F394-840D-36A3-6958-D2E0B0D22B65}"/>
+                <a16:creationId xmlns:a16="http://schemas.microsoft.com/office/drawing/2014/main" id="{ABB4FD19-91DD-AF0C-3DC3-04FD7FDD77B9}"/>
               </a:ext>
             </a:extLst>
           </p:cNvPr>
@@ -5862,7 +5862,7 @@
           <a:bodyPr/>
           <a:lstStyle/>
           <a:p>
-            <a:fld id="{DA01C8C9-DA9E-4EB0-8756-652B0DE35A87}" type="datetimeFigureOut">
+            <a:fld id="{4E307407-BF02-4185-B795-8EFF67E65125}" type="datetimeFigureOut">
               <a:rPr lang="en-US" smtClean="0"/>
               <a:t>10/3/2026</a:t>
             </a:fld>
@@ -5904,7 +5904,7 @@
           <a:bodyPr/>
           <a:lstStyle/>
           <a:p>
-            <a:fld id="{E8DEFA18-2CFA-4775-9ECD-212CDF18C33F}" type="slidenum">
+            <a:fld id="{0901BA54-D28A-46F7-BDED-B9CC383D9A66}" type="slidenum">
               <a:rPr lang="en-US" smtClean="0"/>
               <a:t>‹#›</a:t>
             </a:fld>
@@ -5917,7 +5917,7 @@
           <p:cNvPr id="8" name="item_1_title">
             <a:extLst>
               <a:ext uri="{FF2B5EF4-FFF2-40B4-BE49-F238E27FC236}">
-                <a16:creationId xmlns:a16="http://schemas.microsoft.com/office/drawing/2014/main" id="{098401EA-D838-707C-9BD1-8EC9D459758E}"/>
+                <a16:creationId xmlns:a16="http://schemas.microsoft.com/office/drawing/2014/main" id="{019F1EE1-A24C-D774-4CE6-C4D75C71F837}"/>
               </a:ext>
             </a:extLst>
           </p:cNvPr>
@@ -5967,7 +5967,7 @@
           <p:cNvPr id="9" name="item_1">
             <a:extLst>
               <a:ext uri="{FF2B5EF4-FFF2-40B4-BE49-F238E27FC236}">
-                <a16:creationId xmlns:a16="http://schemas.microsoft.com/office/drawing/2014/main" id="{D61D9CF2-8260-7D02-4BAB-C2525C9335F0}"/>
+                <a16:creationId xmlns:a16="http://schemas.microsoft.com/office/drawing/2014/main" id="{B65ACC20-ED09-1DD8-D453-8D2D1FEE137D}"/>
               </a:ext>
             </a:extLst>
           </p:cNvPr>
@@ -6015,7 +6015,7 @@
           <p:cNvPr id="10" name="item_2_title">
             <a:extLst>
               <a:ext uri="{FF2B5EF4-FFF2-40B4-BE49-F238E27FC236}">
-                <a16:creationId xmlns:a16="http://schemas.microsoft.com/office/drawing/2014/main" id="{F20E8CB7-C878-D159-A9B5-C845EBDE615A}"/>
+                <a16:creationId xmlns:a16="http://schemas.microsoft.com/office/drawing/2014/main" id="{6A09046D-DA52-3DDB-33CA-CD3BD3F1E023}"/>
               </a:ext>
             </a:extLst>
           </p:cNvPr>
@@ -6068,7 +6068,7 @@
           <p:cNvPr id="11" name="item_2">
             <a:extLst>
               <a:ext uri="{FF2B5EF4-FFF2-40B4-BE49-F238E27FC236}">
-                <a16:creationId xmlns:a16="http://schemas.microsoft.com/office/drawing/2014/main" id="{09AE756A-568C-F591-3604-E5F67B0CA984}"/>
+                <a16:creationId xmlns:a16="http://schemas.microsoft.com/office/drawing/2014/main" id="{FE4E05AC-DB35-68AE-5247-CFF89F675AE8}"/>
               </a:ext>
             </a:extLst>
           </p:cNvPr>
@@ -6116,7 +6116,7 @@
           <p:cNvPr id="12" name="item_3_title">
             <a:extLst>
               <a:ext uri="{FF2B5EF4-FFF2-40B4-BE49-F238E27FC236}">
-                <a16:creationId xmlns:a16="http://schemas.microsoft.com/office/drawing/2014/main" id="{F147E9AB-64E2-16AB-A8EF-A460A678E7F0}"/>
+                <a16:creationId xmlns:a16="http://schemas.microsoft.com/office/drawing/2014/main" id="{4B7EBE8D-393C-6D6E-B7BF-6213AD1C7DD4}"/>
               </a:ext>
             </a:extLst>
           </p:cNvPr>
@@ -6169,7 +6169,7 @@
           <p:cNvPr id="13" name="item_3">
             <a:extLst>
               <a:ext uri="{FF2B5EF4-FFF2-40B4-BE49-F238E27FC236}">
-                <a16:creationId xmlns:a16="http://schemas.microsoft.com/office/drawing/2014/main" id="{B37DD394-755B-9989-42FD-87AF720CCF02}"/>
+                <a16:creationId xmlns:a16="http://schemas.microsoft.com/office/drawing/2014/main" id="{8C8F2F72-849F-D54B-F8D6-8174949F1202}"/>
               </a:ext>
             </a:extLst>
           </p:cNvPr>
@@ -6217,7 +6217,7 @@
           <p:cNvPr id="14" name="item_4_title">
             <a:extLst>
               <a:ext uri="{FF2B5EF4-FFF2-40B4-BE49-F238E27FC236}">
-                <a16:creationId xmlns:a16="http://schemas.microsoft.com/office/drawing/2014/main" id="{A94B9F49-E03E-FC3E-1E2E-A863FE71A9FD}"/>
+                <a16:creationId xmlns:a16="http://schemas.microsoft.com/office/drawing/2014/main" id="{734C6F8A-6C4B-689C-612E-4BDABF6C41FF}"/>
               </a:ext>
             </a:extLst>
           </p:cNvPr>
@@ -6270,7 +6270,7 @@
           <p:cNvPr id="15" name="item_4">
             <a:extLst>
               <a:ext uri="{FF2B5EF4-FFF2-40B4-BE49-F238E27FC236}">
-                <a16:creationId xmlns:a16="http://schemas.microsoft.com/office/drawing/2014/main" id="{94413AE8-2C01-0CB1-BDA9-64D57D48D9FD}"/>
+                <a16:creationId xmlns:a16="http://schemas.microsoft.com/office/drawing/2014/main" id="{3A24CB49-7F12-BEC1-5B94-F2DD028744B9}"/>
               </a:ext>
             </a:extLst>
           </p:cNvPr>
@@ -6318,7 +6318,7 @@
           <p:cNvPr id="16" name="source">
             <a:extLst>
               <a:ext uri="{FF2B5EF4-FFF2-40B4-BE49-F238E27FC236}">
-                <a16:creationId xmlns:a16="http://schemas.microsoft.com/office/drawing/2014/main" id="{59BC870D-EDF1-CAD8-AE18-10C7F6F3785C}"/>
+                <a16:creationId xmlns:a16="http://schemas.microsoft.com/office/drawing/2014/main" id="{5ADFDDD1-0C35-E10C-0B07-1BA357DDE8F9}"/>
               </a:ext>
             </a:extLst>
           </p:cNvPr>
@@ -6373,7 +6373,7 @@
     </p:spTree>
     <p:extLst>
       <p:ext uri="{BB962C8B-B14F-4D97-AF65-F5344CB8AC3E}">
-        <p14:creationId xmlns:p14="http://schemas.microsoft.com/office/powerpoint/2010/main" val="791905083"/>
+        <p14:creationId xmlns:p14="http://schemas.microsoft.com/office/powerpoint/2010/main" val="275787186"/>
       </p:ext>
     </p:extLst>
   </p:cSld>
@@ -6405,7 +6405,7 @@
           <p:cNvPr id="7" name="creative_background">
             <a:extLst>
               <a:ext uri="{FF2B5EF4-FFF2-40B4-BE49-F238E27FC236}">
-                <a16:creationId xmlns:a16="http://schemas.microsoft.com/office/drawing/2014/main" id="{21A315F7-7EEC-F66E-0FD7-6D03F349D4E8}"/>
+                <a16:creationId xmlns:a16="http://schemas.microsoft.com/office/drawing/2014/main" id="{306FB033-73D6-5463-9C56-969435EF6540}"/>
               </a:ext>
             </a:extLst>
           </p:cNvPr>
@@ -6478,7 +6478,7 @@
           <a:bodyPr/>
           <a:lstStyle/>
           <a:p>
-            <a:fld id="{DA01C8C9-DA9E-4EB0-8756-652B0DE35A87}" type="datetimeFigureOut">
+            <a:fld id="{4E307407-BF02-4185-B795-8EFF67E65125}" type="datetimeFigureOut">
               <a:rPr lang="en-US" smtClean="0"/>
               <a:t>10/3/2026</a:t>
             </a:fld>
@@ -6520,7 +6520,7 @@
           <a:bodyPr/>
           <a:lstStyle/>
           <a:p>
-            <a:fld id="{E8DEFA18-2CFA-4775-9ECD-212CDF18C33F}" type="slidenum">
+            <a:fld id="{0901BA54-D28A-46F7-BDED-B9CC383D9A66}" type="slidenum">
               <a:rPr lang="en-US" smtClean="0"/>
               <a:t>‹#›</a:t>
             </a:fld>
@@ -6533,7 +6533,7 @@
           <p:cNvPr id="8" name="item_1_title">
             <a:extLst>
               <a:ext uri="{FF2B5EF4-FFF2-40B4-BE49-F238E27FC236}">
-                <a16:creationId xmlns:a16="http://schemas.microsoft.com/office/drawing/2014/main" id="{AF045DF5-C7C2-06DA-216D-49D098CD5DA3}"/>
+                <a16:creationId xmlns:a16="http://schemas.microsoft.com/office/drawing/2014/main" id="{454BE3E4-3751-B507-A330-D92C045207FB}"/>
               </a:ext>
             </a:extLst>
           </p:cNvPr>
@@ -6583,7 +6583,7 @@
           <p:cNvPr id="9" name="item_1">
             <a:extLst>
               <a:ext uri="{FF2B5EF4-FFF2-40B4-BE49-F238E27FC236}">
-                <a16:creationId xmlns:a16="http://schemas.microsoft.com/office/drawing/2014/main" id="{83978752-0F6C-E40B-330E-C05BDCFCDBAC}"/>
+                <a16:creationId xmlns:a16="http://schemas.microsoft.com/office/drawing/2014/main" id="{DCD4DACB-6E3C-83B1-888F-FC14CCFB75CA}"/>
               </a:ext>
             </a:extLst>
           </p:cNvPr>
@@ -6631,7 +6631,7 @@
           <p:cNvPr id="10" name="item_2_title">
             <a:extLst>
               <a:ext uri="{FF2B5EF4-FFF2-40B4-BE49-F238E27FC236}">
-                <a16:creationId xmlns:a16="http://schemas.microsoft.com/office/drawing/2014/main" id="{D832686B-384A-E995-2F86-4FC41DF59FEB}"/>
+                <a16:creationId xmlns:a16="http://schemas.microsoft.com/office/drawing/2014/main" id="{69CEE232-9506-1550-E480-04D59D1998C0}"/>
               </a:ext>
             </a:extLst>
           </p:cNvPr>
@@ -6684,7 +6684,7 @@
           <p:cNvPr id="11" name="item_2">
             <a:extLst>
               <a:ext uri="{FF2B5EF4-FFF2-40B4-BE49-F238E27FC236}">
-                <a16:creationId xmlns:a16="http://schemas.microsoft.com/office/drawing/2014/main" id="{88E30A5B-0D8F-9813-82F1-69BD8A06A63C}"/>
+                <a16:creationId xmlns:a16="http://schemas.microsoft.com/office/drawing/2014/main" id="{DAF4CA61-790C-5D61-672E-280599DE8311}"/>
               </a:ext>
             </a:extLst>
           </p:cNvPr>
@@ -6732,7 +6732,7 @@
           <p:cNvPr id="12" name="item_3_title">
             <a:extLst>
               <a:ext uri="{FF2B5EF4-FFF2-40B4-BE49-F238E27FC236}">
-                <a16:creationId xmlns:a16="http://schemas.microsoft.com/office/drawing/2014/main" id="{63446CE3-3454-15BE-EAD1-8C015575B6EB}"/>
+                <a16:creationId xmlns:a16="http://schemas.microsoft.com/office/drawing/2014/main" id="{00534EE7-113E-0768-4033-084472F6914C}"/>
               </a:ext>
             </a:extLst>
           </p:cNvPr>
@@ -6785,7 +6785,7 @@
           <p:cNvPr id="13" name="item_3">
             <a:extLst>
               <a:ext uri="{FF2B5EF4-FFF2-40B4-BE49-F238E27FC236}">
-                <a16:creationId xmlns:a16="http://schemas.microsoft.com/office/drawing/2014/main" id="{E63FCF14-B458-1C34-702D-DAD76F541FC3}"/>
+                <a16:creationId xmlns:a16="http://schemas.microsoft.com/office/drawing/2014/main" id="{4ECA3EED-87BA-8EB4-A8C4-D42B3666E675}"/>
               </a:ext>
             </a:extLst>
           </p:cNvPr>
@@ -6833,7 +6833,7 @@
           <p:cNvPr id="14" name="item_4_title">
             <a:extLst>
               <a:ext uri="{FF2B5EF4-FFF2-40B4-BE49-F238E27FC236}">
-                <a16:creationId xmlns:a16="http://schemas.microsoft.com/office/drawing/2014/main" id="{D0BD07EC-08A5-E398-7061-F71CAADFE3AC}"/>
+                <a16:creationId xmlns:a16="http://schemas.microsoft.com/office/drawing/2014/main" id="{1EC08B57-34C2-169D-CADB-B9FE8D0B0396}"/>
               </a:ext>
             </a:extLst>
           </p:cNvPr>
@@ -6886,7 +6886,7 @@
           <p:cNvPr id="15" name="item_4">
             <a:extLst>
               <a:ext uri="{FF2B5EF4-FFF2-40B4-BE49-F238E27FC236}">
-                <a16:creationId xmlns:a16="http://schemas.microsoft.com/office/drawing/2014/main" id="{402E0E0B-E7FE-0564-BF73-4D38C14802F3}"/>
+                <a16:creationId xmlns:a16="http://schemas.microsoft.com/office/drawing/2014/main" id="{77A2D4EA-F4C1-B555-EB07-5EB91B46CE63}"/>
               </a:ext>
             </a:extLst>
           </p:cNvPr>
@@ -6934,7 +6934,7 @@
           <p:cNvPr id="16" name="source">
             <a:extLst>
               <a:ext uri="{FF2B5EF4-FFF2-40B4-BE49-F238E27FC236}">
-                <a16:creationId xmlns:a16="http://schemas.microsoft.com/office/drawing/2014/main" id="{0D5AB97F-FCF2-C514-65C5-3F85CC5F6A10}"/>
+                <a16:creationId xmlns:a16="http://schemas.microsoft.com/office/drawing/2014/main" id="{081F3392-52C5-674E-D898-4CE3288BE47B}"/>
               </a:ext>
             </a:extLst>
           </p:cNvPr>
@@ -6989,7 +6989,7 @@
     </p:spTree>
     <p:extLst>
       <p:ext uri="{BB962C8B-B14F-4D97-AF65-F5344CB8AC3E}">
-        <p14:creationId xmlns:p14="http://schemas.microsoft.com/office/powerpoint/2010/main" val="952652901"/>
+        <p14:creationId xmlns:p14="http://schemas.microsoft.com/office/powerpoint/2010/main" val="1500588808"/>
       </p:ext>
     </p:extLst>
   </p:cSld>
@@ -7021,7 +7021,7 @@
           <p:cNvPr id="7" name="creative_background">
             <a:extLst>
               <a:ext uri="{FF2B5EF4-FFF2-40B4-BE49-F238E27FC236}">
-                <a16:creationId xmlns:a16="http://schemas.microsoft.com/office/drawing/2014/main" id="{CAFA6F05-A17A-66A8-7254-EB48979AA69B}"/>
+                <a16:creationId xmlns:a16="http://schemas.microsoft.com/office/drawing/2014/main" id="{B4790FF7-2D26-9E06-0E30-60B61A9A8A1F}"/>
               </a:ext>
             </a:extLst>
           </p:cNvPr>
@@ -7094,7 +7094,7 @@
           <a:bodyPr/>
           <a:lstStyle/>
           <a:p>
-            <a:fld id="{DA01C8C9-DA9E-4EB0-8756-652B0DE35A87}" type="datetimeFigureOut">
+            <a:fld id="{4E307407-BF02-4185-B795-8EFF67E65125}" type="datetimeFigureOut">
               <a:rPr lang="en-US" smtClean="0"/>
               <a:t>10/3/2026</a:t>
             </a:fld>
@@ -7136,7 +7136,7 @@
           <a:bodyPr/>
           <a:lstStyle/>
           <a:p>
-            <a:fld id="{E8DEFA18-2CFA-4775-9ECD-212CDF18C33F}" type="slidenum">
+            <a:fld id="{0901BA54-D28A-46F7-BDED-B9CC383D9A66}" type="slidenum">
               <a:rPr lang="en-US" smtClean="0"/>
               <a:t>‹#›</a:t>
             </a:fld>
@@ -7149,7 +7149,7 @@
           <p:cNvPr id="8" name="kpi_value_1">
             <a:extLst>
               <a:ext uri="{FF2B5EF4-FFF2-40B4-BE49-F238E27FC236}">
-                <a16:creationId xmlns:a16="http://schemas.microsoft.com/office/drawing/2014/main" id="{4D73FA2C-626E-488E-8CAA-76C24A01D67B}"/>
+                <a16:creationId xmlns:a16="http://schemas.microsoft.com/office/drawing/2014/main" id="{4A9202C5-726B-F9D1-C3CA-127F2989043D}"/>
               </a:ext>
             </a:extLst>
           </p:cNvPr>
@@ -7199,7 +7199,7 @@
           <p:cNvPr id="9" name="kpi_label_1">
             <a:extLst>
               <a:ext uri="{FF2B5EF4-FFF2-40B4-BE49-F238E27FC236}">
-                <a16:creationId xmlns:a16="http://schemas.microsoft.com/office/drawing/2014/main" id="{4AA07E09-4667-835D-51A7-67A1C0384257}"/>
+                <a16:creationId xmlns:a16="http://schemas.microsoft.com/office/drawing/2014/main" id="{D61E4909-6E06-C10C-2741-8FA53D25EA61}"/>
               </a:ext>
             </a:extLst>
           </p:cNvPr>
@@ -7247,7 +7247,7 @@
           <p:cNvPr id="10" name="quote">
             <a:extLst>
               <a:ext uri="{FF2B5EF4-FFF2-40B4-BE49-F238E27FC236}">
-                <a16:creationId xmlns:a16="http://schemas.microsoft.com/office/drawing/2014/main" id="{CAC84AE9-E18B-0FC5-CB66-A3211C02EE85}"/>
+                <a16:creationId xmlns:a16="http://schemas.microsoft.com/office/drawing/2014/main" id="{42B5FEDE-AF03-DDCC-46C5-96632AFB1BE6}"/>
               </a:ext>
             </a:extLst>
           </p:cNvPr>
@@ -7297,7 +7297,7 @@
           <p:cNvPr id="11" name="attribution">
             <a:extLst>
               <a:ext uri="{FF2B5EF4-FFF2-40B4-BE49-F238E27FC236}">
-                <a16:creationId xmlns:a16="http://schemas.microsoft.com/office/drawing/2014/main" id="{3B0B84C2-D47C-0DFF-65D8-32EEF7E9449B}"/>
+                <a16:creationId xmlns:a16="http://schemas.microsoft.com/office/drawing/2014/main" id="{B766A1DE-FA98-863A-D93D-FCE1C3FD5AE1}"/>
               </a:ext>
             </a:extLst>
           </p:cNvPr>
@@ -7345,7 +7345,7 @@
           <p:cNvPr id="12" name="item_1_title">
             <a:extLst>
               <a:ext uri="{FF2B5EF4-FFF2-40B4-BE49-F238E27FC236}">
-                <a16:creationId xmlns:a16="http://schemas.microsoft.com/office/drawing/2014/main" id="{D730FEE2-6994-9923-3B0E-FBC1CD36F7D7}"/>
+                <a16:creationId xmlns:a16="http://schemas.microsoft.com/office/drawing/2014/main" id="{9DB58008-00E3-B87A-375D-902BBD6CEFA8}"/>
               </a:ext>
             </a:extLst>
           </p:cNvPr>
@@ -7398,7 +7398,7 @@
           <p:cNvPr id="13" name="item_1">
             <a:extLst>
               <a:ext uri="{FF2B5EF4-FFF2-40B4-BE49-F238E27FC236}">
-                <a16:creationId xmlns:a16="http://schemas.microsoft.com/office/drawing/2014/main" id="{555B4AE2-34EC-6071-5106-46E946191523}"/>
+                <a16:creationId xmlns:a16="http://schemas.microsoft.com/office/drawing/2014/main" id="{E78C0EDD-891D-AC01-EE18-844623ACAA6F}"/>
               </a:ext>
             </a:extLst>
           </p:cNvPr>
@@ -7446,7 +7446,7 @@
           <p:cNvPr id="14" name="source">
             <a:extLst>
               <a:ext uri="{FF2B5EF4-FFF2-40B4-BE49-F238E27FC236}">
-                <a16:creationId xmlns:a16="http://schemas.microsoft.com/office/drawing/2014/main" id="{B845F7A4-D139-8E1E-8733-10757AE7AB50}"/>
+                <a16:creationId xmlns:a16="http://schemas.microsoft.com/office/drawing/2014/main" id="{21765295-4A39-3E61-8E4F-140AED3708C6}"/>
               </a:ext>
             </a:extLst>
           </p:cNvPr>
@@ -7501,7 +7501,7 @@
     </p:spTree>
     <p:extLst>
       <p:ext uri="{BB962C8B-B14F-4D97-AF65-F5344CB8AC3E}">
-        <p14:creationId xmlns:p14="http://schemas.microsoft.com/office/powerpoint/2010/main" val="3039959545"/>
+        <p14:creationId xmlns:p14="http://schemas.microsoft.com/office/powerpoint/2010/main" val="56464155"/>
       </p:ext>
     </p:extLst>
   </p:cSld>
@@ -7533,7 +7533,7 @@
           <p:cNvPr id="7" name="creative_background">
             <a:extLst>
               <a:ext uri="{FF2B5EF4-FFF2-40B4-BE49-F238E27FC236}">
-                <a16:creationId xmlns:a16="http://schemas.microsoft.com/office/drawing/2014/main" id="{68ED24CE-0CA6-A324-84F2-567460D0811C}"/>
+                <a16:creationId xmlns:a16="http://schemas.microsoft.com/office/drawing/2014/main" id="{5E3753B9-398D-FED3-E5B1-06DFA6A846B3}"/>
               </a:ext>
             </a:extLst>
           </p:cNvPr>
@@ -7606,7 +7606,7 @@
           <a:bodyPr/>
           <a:lstStyle/>
           <a:p>
-            <a:fld id="{DA01C8C9-DA9E-4EB0-8756-652B0DE35A87}" type="datetimeFigureOut">
+            <a:fld id="{4E307407-BF02-4185-B795-8EFF67E65125}" type="datetimeFigureOut">
               <a:rPr lang="en-US" smtClean="0"/>
               <a:t>10/3/2026</a:t>
             </a:fld>
@@ -7648,7 +7648,7 @@
           <a:bodyPr/>
           <a:lstStyle/>
           <a:p>
-            <a:fld id="{E8DEFA18-2CFA-4775-9ECD-212CDF18C33F}" type="slidenum">
+            <a:fld id="{0901BA54-D28A-46F7-BDED-B9CC383D9A66}" type="slidenum">
               <a:rPr lang="en-US" smtClean="0"/>
               <a:t>‹#›</a:t>
             </a:fld>
@@ -7661,7 +7661,7 @@
           <p:cNvPr id="8" name="item_1_title">
             <a:extLst>
               <a:ext uri="{FF2B5EF4-FFF2-40B4-BE49-F238E27FC236}">
-                <a16:creationId xmlns:a16="http://schemas.microsoft.com/office/drawing/2014/main" id="{CCE7E69A-4E7F-6F48-C8A7-02BBBF10E8E6}"/>
+                <a16:creationId xmlns:a16="http://schemas.microsoft.com/office/drawing/2014/main" id="{6206B911-0F1F-E665-D49D-703DD444477D}"/>
               </a:ext>
             </a:extLst>
           </p:cNvPr>
@@ -7711,7 +7711,7 @@
           <p:cNvPr id="9" name="item_1">
             <a:extLst>
               <a:ext uri="{FF2B5EF4-FFF2-40B4-BE49-F238E27FC236}">
-                <a16:creationId xmlns:a16="http://schemas.microsoft.com/office/drawing/2014/main" id="{0F2BF937-B48C-847F-DE44-70E45C82EABA}"/>
+                <a16:creationId xmlns:a16="http://schemas.microsoft.com/office/drawing/2014/main" id="{E72007E5-AE77-A401-3EB3-4A10E739EFC5}"/>
               </a:ext>
             </a:extLst>
           </p:cNvPr>
@@ -7759,7 +7759,7 @@
           <p:cNvPr id="10" name="item_2_title">
             <a:extLst>
               <a:ext uri="{FF2B5EF4-FFF2-40B4-BE49-F238E27FC236}">
-                <a16:creationId xmlns:a16="http://schemas.microsoft.com/office/drawing/2014/main" id="{79EA3555-CA55-6BBD-6934-0BA1691C4875}"/>
+                <a16:creationId xmlns:a16="http://schemas.microsoft.com/office/drawing/2014/main" id="{8744D543-5328-3952-516A-B80CF6A39D18}"/>
               </a:ext>
             </a:extLst>
           </p:cNvPr>
@@ -7812,7 +7812,7 @@
           <p:cNvPr id="11" name="item_2">
             <a:extLst>
               <a:ext uri="{FF2B5EF4-FFF2-40B4-BE49-F238E27FC236}">
-                <a16:creationId xmlns:a16="http://schemas.microsoft.com/office/drawing/2014/main" id="{A20B9B8D-982C-AC8E-35C1-D4BE24EC4D66}"/>
+                <a16:creationId xmlns:a16="http://schemas.microsoft.com/office/drawing/2014/main" id="{B380B617-4EB2-F484-1A37-E18D109BDD3C}"/>
               </a:ext>
             </a:extLst>
           </p:cNvPr>
@@ -7860,7 +7860,7 @@
           <p:cNvPr id="12" name="item_3_title">
             <a:extLst>
               <a:ext uri="{FF2B5EF4-FFF2-40B4-BE49-F238E27FC236}">
-                <a16:creationId xmlns:a16="http://schemas.microsoft.com/office/drawing/2014/main" id="{C7445A3D-3F26-51DB-A02D-3A443D983485}"/>
+                <a16:creationId xmlns:a16="http://schemas.microsoft.com/office/drawing/2014/main" id="{E06B734C-C5A6-ECC5-F30A-7A4779F94E0F}"/>
               </a:ext>
             </a:extLst>
           </p:cNvPr>
@@ -7913,7 +7913,7 @@
           <p:cNvPr id="13" name="item_3">
             <a:extLst>
               <a:ext uri="{FF2B5EF4-FFF2-40B4-BE49-F238E27FC236}">
-                <a16:creationId xmlns:a16="http://schemas.microsoft.com/office/drawing/2014/main" id="{A9F9F6B9-F831-A688-03A3-57AF482B61F3}"/>
+                <a16:creationId xmlns:a16="http://schemas.microsoft.com/office/drawing/2014/main" id="{68504AED-8234-852B-D69E-D9E427853BF5}"/>
               </a:ext>
             </a:extLst>
           </p:cNvPr>
@@ -7961,7 +7961,7 @@
           <p:cNvPr id="14" name="source">
             <a:extLst>
               <a:ext uri="{FF2B5EF4-FFF2-40B4-BE49-F238E27FC236}">
-                <a16:creationId xmlns:a16="http://schemas.microsoft.com/office/drawing/2014/main" id="{142F7677-228C-EA01-2BBD-5F025A24DDCC}"/>
+                <a16:creationId xmlns:a16="http://schemas.microsoft.com/office/drawing/2014/main" id="{41A2C7B3-6F51-A4B4-8224-86194070B52E}"/>
               </a:ext>
             </a:extLst>
           </p:cNvPr>
@@ -8016,7 +8016,7 @@
     </p:spTree>
     <p:extLst>
       <p:ext uri="{BB962C8B-B14F-4D97-AF65-F5344CB8AC3E}">
-        <p14:creationId xmlns:p14="http://schemas.microsoft.com/office/powerpoint/2010/main" val="1115853294"/>
+        <p14:creationId xmlns:p14="http://schemas.microsoft.com/office/powerpoint/2010/main" val="2104115063"/>
       </p:ext>
     </p:extLst>
   </p:cSld>
@@ -8048,7 +8048,7 @@
           <p:cNvPr id="7" name="creative_background">
             <a:extLst>
               <a:ext uri="{FF2B5EF4-FFF2-40B4-BE49-F238E27FC236}">
-                <a16:creationId xmlns:a16="http://schemas.microsoft.com/office/drawing/2014/main" id="{82652A9A-D14E-408B-FE25-0AC721568823}"/>
+                <a16:creationId xmlns:a16="http://schemas.microsoft.com/office/drawing/2014/main" id="{326FD528-512B-5E53-6617-8459B68C34F3}"/>
               </a:ext>
             </a:extLst>
           </p:cNvPr>
@@ -8121,7 +8121,7 @@
           <a:bodyPr/>
           <a:lstStyle/>
           <a:p>
-            <a:fld id="{DA01C8C9-DA9E-4EB0-8756-652B0DE35A87}" type="datetimeFigureOut">
+            <a:fld id="{4E307407-BF02-4185-B795-8EFF67E65125}" type="datetimeFigureOut">
               <a:rPr lang="en-US" smtClean="0"/>
               <a:t>10/3/2026</a:t>
             </a:fld>
@@ -8163,7 +8163,7 @@
           <a:bodyPr/>
           <a:lstStyle/>
           <a:p>
-            <a:fld id="{E8DEFA18-2CFA-4775-9ECD-212CDF18C33F}" type="slidenum">
+            <a:fld id="{0901BA54-D28A-46F7-BDED-B9CC383D9A66}" type="slidenum">
               <a:rPr lang="en-US" smtClean="0"/>
               <a:t>‹#›</a:t>
             </a:fld>
@@ -8176,7 +8176,7 @@
           <p:cNvPr id="8" name="marker_1">
             <a:extLst>
               <a:ext uri="{FF2B5EF4-FFF2-40B4-BE49-F238E27FC236}">
-                <a16:creationId xmlns:a16="http://schemas.microsoft.com/office/drawing/2014/main" id="{18DEF028-E3AF-9613-178E-7B907EDEDA1A}"/>
+                <a16:creationId xmlns:a16="http://schemas.microsoft.com/office/drawing/2014/main" id="{710F4AB2-E2C0-B1DE-9B68-7D29AC92D312}"/>
               </a:ext>
             </a:extLst>
           </p:cNvPr>
@@ -8232,7 +8232,7 @@
           <p:cNvPr id="9" name="item_1_title">
             <a:extLst>
               <a:ext uri="{FF2B5EF4-FFF2-40B4-BE49-F238E27FC236}">
-                <a16:creationId xmlns:a16="http://schemas.microsoft.com/office/drawing/2014/main" id="{4826D9FD-F726-F39D-57E1-C80C6DDAE345}"/>
+                <a16:creationId xmlns:a16="http://schemas.microsoft.com/office/drawing/2014/main" id="{C8CF3DD8-7EAE-AF9D-29DF-E1F4AE544713}"/>
               </a:ext>
             </a:extLst>
           </p:cNvPr>
@@ -8285,7 +8285,7 @@
           <p:cNvPr id="10" name="item_1">
             <a:extLst>
               <a:ext uri="{FF2B5EF4-FFF2-40B4-BE49-F238E27FC236}">
-                <a16:creationId xmlns:a16="http://schemas.microsoft.com/office/drawing/2014/main" id="{ED96086A-9AAE-5715-85BB-C15A2F1E7D95}"/>
+                <a16:creationId xmlns:a16="http://schemas.microsoft.com/office/drawing/2014/main" id="{58C20BF1-4BEF-2469-39BF-398F607C1787}"/>
               </a:ext>
             </a:extLst>
           </p:cNvPr>
@@ -8333,7 +8333,7 @@
           <p:cNvPr id="11" name="marker_2">
             <a:extLst>
               <a:ext uri="{FF2B5EF4-FFF2-40B4-BE49-F238E27FC236}">
-                <a16:creationId xmlns:a16="http://schemas.microsoft.com/office/drawing/2014/main" id="{27D409FF-E438-61E5-0EE2-4E7993C4E542}"/>
+                <a16:creationId xmlns:a16="http://schemas.microsoft.com/office/drawing/2014/main" id="{E893BBDA-DD2B-F66D-9C91-35C616E6230D}"/>
               </a:ext>
             </a:extLst>
           </p:cNvPr>
@@ -8389,7 +8389,7 @@
           <p:cNvPr id="12" name="item_2_title">
             <a:extLst>
               <a:ext uri="{FF2B5EF4-FFF2-40B4-BE49-F238E27FC236}">
-                <a16:creationId xmlns:a16="http://schemas.microsoft.com/office/drawing/2014/main" id="{EFEEC087-0390-EC7E-11BC-8CEF0749FC51}"/>
+                <a16:creationId xmlns:a16="http://schemas.microsoft.com/office/drawing/2014/main" id="{63C473AC-1F88-8563-9863-075397264CC9}"/>
               </a:ext>
             </a:extLst>
           </p:cNvPr>
@@ -8442,7 +8442,7 @@
           <p:cNvPr id="13" name="item_2">
             <a:extLst>
               <a:ext uri="{FF2B5EF4-FFF2-40B4-BE49-F238E27FC236}">
-                <a16:creationId xmlns:a16="http://schemas.microsoft.com/office/drawing/2014/main" id="{7142EFA2-3463-6E48-A52B-496654DF65F5}"/>
+                <a16:creationId xmlns:a16="http://schemas.microsoft.com/office/drawing/2014/main" id="{E0D75902-7869-78E0-62D6-E63B169C17F6}"/>
               </a:ext>
             </a:extLst>
           </p:cNvPr>
@@ -8490,7 +8490,7 @@
           <p:cNvPr id="14" name="source">
             <a:extLst>
               <a:ext uri="{FF2B5EF4-FFF2-40B4-BE49-F238E27FC236}">
-                <a16:creationId xmlns:a16="http://schemas.microsoft.com/office/drawing/2014/main" id="{0CFA3011-4220-E3F2-469F-F38CAF929C8C}"/>
+                <a16:creationId xmlns:a16="http://schemas.microsoft.com/office/drawing/2014/main" id="{83650018-503A-5FD3-9F8D-CC73E221FE58}"/>
               </a:ext>
             </a:extLst>
           </p:cNvPr>
@@ -8545,7 +8545,7 @@
     </p:spTree>
     <p:extLst>
       <p:ext uri="{BB962C8B-B14F-4D97-AF65-F5344CB8AC3E}">
-        <p14:creationId xmlns:p14="http://schemas.microsoft.com/office/powerpoint/2010/main" val="1805159930"/>
+        <p14:creationId xmlns:p14="http://schemas.microsoft.com/office/powerpoint/2010/main" val="2018194338"/>
       </p:ext>
     </p:extLst>
   </p:cSld>
@@ -8577,7 +8577,7 @@
           <p:cNvPr id="7" name="creative_background">
             <a:extLst>
               <a:ext uri="{FF2B5EF4-FFF2-40B4-BE49-F238E27FC236}">
-                <a16:creationId xmlns:a16="http://schemas.microsoft.com/office/drawing/2014/main" id="{E9462B24-8A43-9B4C-220C-F6EF37749756}"/>
+                <a16:creationId xmlns:a16="http://schemas.microsoft.com/office/drawing/2014/main" id="{0FF5D344-2829-53E9-0947-63813843B70A}"/>
               </a:ext>
             </a:extLst>
           </p:cNvPr>
@@ -8650,7 +8650,7 @@
           <a:bodyPr/>
           <a:lstStyle/>
           <a:p>
-            <a:fld id="{DA01C8C9-DA9E-4EB0-8756-652B0DE35A87}" type="datetimeFigureOut">
+            <a:fld id="{4E307407-BF02-4185-B795-8EFF67E65125}" type="datetimeFigureOut">
               <a:rPr lang="en-US" smtClean="0"/>
               <a:t>10/3/2026</a:t>
             </a:fld>
@@ -8692,7 +8692,7 @@
           <a:bodyPr/>
           <a:lstStyle/>
           <a:p>
-            <a:fld id="{E8DEFA18-2CFA-4775-9ECD-212CDF18C33F}" type="slidenum">
+            <a:fld id="{0901BA54-D28A-46F7-BDED-B9CC383D9A66}" type="slidenum">
               <a:rPr lang="en-US" smtClean="0"/>
               <a:t>‹#›</a:t>
             </a:fld>
@@ -8705,7 +8705,7 @@
           <p:cNvPr id="8" name="kpi_value_1">
             <a:extLst>
               <a:ext uri="{FF2B5EF4-FFF2-40B4-BE49-F238E27FC236}">
-                <a16:creationId xmlns:a16="http://schemas.microsoft.com/office/drawing/2014/main" id="{7145E440-A852-B10E-259A-40580A2E2EF9}"/>
+                <a16:creationId xmlns:a16="http://schemas.microsoft.com/office/drawing/2014/main" id="{74308A1F-205B-931F-98D9-C4152C9F07BA}"/>
               </a:ext>
             </a:extLst>
           </p:cNvPr>
@@ -8755,7 +8755,7 @@
           <p:cNvPr id="9" name="kpi_label_1">
             <a:extLst>
               <a:ext uri="{FF2B5EF4-FFF2-40B4-BE49-F238E27FC236}">
-                <a16:creationId xmlns:a16="http://schemas.microsoft.com/office/drawing/2014/main" id="{137BF7B8-8F05-5F44-4A36-0597E3D1110A}"/>
+                <a16:creationId xmlns:a16="http://schemas.microsoft.com/office/drawing/2014/main" id="{66A35EEA-45DF-8672-28D8-DD5752ED09DB}"/>
               </a:ext>
             </a:extLst>
           </p:cNvPr>
@@ -8803,7 +8803,7 @@
           <p:cNvPr id="10" name="quote">
             <a:extLst>
               <a:ext uri="{FF2B5EF4-FFF2-40B4-BE49-F238E27FC236}">
-                <a16:creationId xmlns:a16="http://schemas.microsoft.com/office/drawing/2014/main" id="{FADE3250-CC28-07BA-A9EF-6A61FA1E859C}"/>
+                <a16:creationId xmlns:a16="http://schemas.microsoft.com/office/drawing/2014/main" id="{7EF2310F-31EA-877D-021D-A09B03B8C34F}"/>
               </a:ext>
             </a:extLst>
           </p:cNvPr>
@@ -8853,7 +8853,7 @@
           <p:cNvPr id="11" name="attribution">
             <a:extLst>
               <a:ext uri="{FF2B5EF4-FFF2-40B4-BE49-F238E27FC236}">
-                <a16:creationId xmlns:a16="http://schemas.microsoft.com/office/drawing/2014/main" id="{C30810E2-74F6-E39E-9140-23E44A69893B}"/>
+                <a16:creationId xmlns:a16="http://schemas.microsoft.com/office/drawing/2014/main" id="{109B4925-2590-7ADD-BDA4-42F2265BC0FA}"/>
               </a:ext>
             </a:extLst>
           </p:cNvPr>
@@ -8901,7 +8901,7 @@
           <p:cNvPr id="12" name="item_1_title">
             <a:extLst>
               <a:ext uri="{FF2B5EF4-FFF2-40B4-BE49-F238E27FC236}">
-                <a16:creationId xmlns:a16="http://schemas.microsoft.com/office/drawing/2014/main" id="{8BE2BEBD-6DE4-C660-E68A-C578FECAA66C}"/>
+                <a16:creationId xmlns:a16="http://schemas.microsoft.com/office/drawing/2014/main" id="{ED7F8E48-6539-64CC-F274-CE542C8843FB}"/>
               </a:ext>
             </a:extLst>
           </p:cNvPr>
@@ -8954,7 +8954,7 @@
           <p:cNvPr id="13" name="item_1">
             <a:extLst>
               <a:ext uri="{FF2B5EF4-FFF2-40B4-BE49-F238E27FC236}">
-                <a16:creationId xmlns:a16="http://schemas.microsoft.com/office/drawing/2014/main" id="{3B4813A7-257D-7623-6B7A-36B28CA35A8A}"/>
+                <a16:creationId xmlns:a16="http://schemas.microsoft.com/office/drawing/2014/main" id="{09245E69-13CE-9C1A-755A-E883EEC55995}"/>
               </a:ext>
             </a:extLst>
           </p:cNvPr>
@@ -9002,7 +9002,7 @@
           <p:cNvPr id="14" name="source">
             <a:extLst>
               <a:ext uri="{FF2B5EF4-FFF2-40B4-BE49-F238E27FC236}">
-                <a16:creationId xmlns:a16="http://schemas.microsoft.com/office/drawing/2014/main" id="{53169C2E-9A6F-A710-73FA-EB67F7E315C0}"/>
+                <a16:creationId xmlns:a16="http://schemas.microsoft.com/office/drawing/2014/main" id="{A6A5BBC8-CDD8-7927-60C8-AE9B29140041}"/>
               </a:ext>
             </a:extLst>
           </p:cNvPr>
@@ -9057,7 +9057,7 @@
     </p:spTree>
     <p:extLst>
       <p:ext uri="{BB962C8B-B14F-4D97-AF65-F5344CB8AC3E}">
-        <p14:creationId xmlns:p14="http://schemas.microsoft.com/office/powerpoint/2010/main" val="2225524443"/>
+        <p14:creationId xmlns:p14="http://schemas.microsoft.com/office/powerpoint/2010/main" val="3101508610"/>
       </p:ext>
     </p:extLst>
   </p:cSld>
@@ -9089,7 +9089,7 @@
           <p:cNvPr id="7" name="creative_background">
             <a:extLst>
               <a:ext uri="{FF2B5EF4-FFF2-40B4-BE49-F238E27FC236}">
-                <a16:creationId xmlns:a16="http://schemas.microsoft.com/office/drawing/2014/main" id="{28E70041-0497-1801-EE3D-DFB8B150FD6D}"/>
+                <a16:creationId xmlns:a16="http://schemas.microsoft.com/office/drawing/2014/main" id="{F7F29C11-C7E2-5B6A-B5D0-7AE2C06DE54E}"/>
               </a:ext>
             </a:extLst>
           </p:cNvPr>
@@ -9162,7 +9162,7 @@
           <a:bodyPr/>
           <a:lstStyle/>
           <a:p>
-            <a:fld id="{DA01C8C9-DA9E-4EB0-8756-652B0DE35A87}" type="datetimeFigureOut">
+            <a:fld id="{4E307407-BF02-4185-B795-8EFF67E65125}" type="datetimeFigureOut">
               <a:rPr lang="en-US" smtClean="0"/>
               <a:t>10/3/2026</a:t>
             </a:fld>
@@ -9204,7 +9204,7 @@
           <a:bodyPr/>
           <a:lstStyle/>
           <a:p>
-            <a:fld id="{E8DEFA18-2CFA-4775-9ECD-212CDF18C33F}" type="slidenum">
+            <a:fld id="{0901BA54-D28A-46F7-BDED-B9CC383D9A66}" type="slidenum">
               <a:rPr lang="en-US" smtClean="0"/>
               <a:t>‹#›</a:t>
             </a:fld>
@@ -9217,7 +9217,7 @@
           <p:cNvPr id="8" name="marker_1">
             <a:extLst>
               <a:ext uri="{FF2B5EF4-FFF2-40B4-BE49-F238E27FC236}">
-                <a16:creationId xmlns:a16="http://schemas.microsoft.com/office/drawing/2014/main" id="{FF45BA33-1CF5-21EE-E2C1-1E91946720D0}"/>
+                <a16:creationId xmlns:a16="http://schemas.microsoft.com/office/drawing/2014/main" id="{7A4F5DAB-D0A5-3CED-513C-C2EEB94FFB07}"/>
               </a:ext>
             </a:extLst>
           </p:cNvPr>
@@ -9273,7 +9273,7 @@
           <p:cNvPr id="9" name="item_1">
             <a:extLst>
               <a:ext uri="{FF2B5EF4-FFF2-40B4-BE49-F238E27FC236}">
-                <a16:creationId xmlns:a16="http://schemas.microsoft.com/office/drawing/2014/main" id="{0066EA4B-8F7C-7A80-4728-69B9867759C5}"/>
+                <a16:creationId xmlns:a16="http://schemas.microsoft.com/office/drawing/2014/main" id="{276F9AAC-09A5-437C-58B0-EDEDC7670BEE}"/>
               </a:ext>
             </a:extLst>
           </p:cNvPr>
@@ -9321,7 +9321,7 @@
           <p:cNvPr id="10" name="marker_2">
             <a:extLst>
               <a:ext uri="{FF2B5EF4-FFF2-40B4-BE49-F238E27FC236}">
-                <a16:creationId xmlns:a16="http://schemas.microsoft.com/office/drawing/2014/main" id="{091E29A8-7DC4-35E1-D682-9DDE59738157}"/>
+                <a16:creationId xmlns:a16="http://schemas.microsoft.com/office/drawing/2014/main" id="{8AAF4F52-7B49-BE7F-4470-EA6FD6381285}"/>
               </a:ext>
             </a:extLst>
           </p:cNvPr>
@@ -9377,7 +9377,7 @@
           <p:cNvPr id="11" name="item_2">
             <a:extLst>
               <a:ext uri="{FF2B5EF4-FFF2-40B4-BE49-F238E27FC236}">
-                <a16:creationId xmlns:a16="http://schemas.microsoft.com/office/drawing/2014/main" id="{1A3D48E7-E734-34B3-4E34-8EB470EFBD8C}"/>
+                <a16:creationId xmlns:a16="http://schemas.microsoft.com/office/drawing/2014/main" id="{5623F7C4-A910-2EF6-CD57-CA8A8F626212}"/>
               </a:ext>
             </a:extLst>
           </p:cNvPr>
@@ -9425,7 +9425,7 @@
           <p:cNvPr id="12" name="marker_3">
             <a:extLst>
               <a:ext uri="{FF2B5EF4-FFF2-40B4-BE49-F238E27FC236}">
-                <a16:creationId xmlns:a16="http://schemas.microsoft.com/office/drawing/2014/main" id="{95DC1EE3-F42E-271B-0437-CAF810B8CA62}"/>
+                <a16:creationId xmlns:a16="http://schemas.microsoft.com/office/drawing/2014/main" id="{F78E2F4F-CB78-7F98-1E89-AB59C37AF436}"/>
               </a:ext>
             </a:extLst>
           </p:cNvPr>
@@ -9481,7 +9481,7 @@
           <p:cNvPr id="13" name="item_3">
             <a:extLst>
               <a:ext uri="{FF2B5EF4-FFF2-40B4-BE49-F238E27FC236}">
-                <a16:creationId xmlns:a16="http://schemas.microsoft.com/office/drawing/2014/main" id="{08659DC6-4DE8-B717-3290-9ADEF815AF64}"/>
+                <a16:creationId xmlns:a16="http://schemas.microsoft.com/office/drawing/2014/main" id="{1B845D4D-2F3D-A557-0FCD-F8A383E2517F}"/>
               </a:ext>
             </a:extLst>
           </p:cNvPr>
@@ -9529,7 +9529,7 @@
           <p:cNvPr id="14" name="marker_4">
             <a:extLst>
               <a:ext uri="{FF2B5EF4-FFF2-40B4-BE49-F238E27FC236}">
-                <a16:creationId xmlns:a16="http://schemas.microsoft.com/office/drawing/2014/main" id="{A2484263-1172-EEF3-CEC8-748EC5D7DFCD}"/>
+                <a16:creationId xmlns:a16="http://schemas.microsoft.com/office/drawing/2014/main" id="{A66A2C99-B75E-7595-CF98-A338E46C1536}"/>
               </a:ext>
             </a:extLst>
           </p:cNvPr>
@@ -9585,7 +9585,7 @@
           <p:cNvPr id="15" name="item_4">
             <a:extLst>
               <a:ext uri="{FF2B5EF4-FFF2-40B4-BE49-F238E27FC236}">
-                <a16:creationId xmlns:a16="http://schemas.microsoft.com/office/drawing/2014/main" id="{089D1578-3395-2170-8F12-54069A293B0C}"/>
+                <a16:creationId xmlns:a16="http://schemas.microsoft.com/office/drawing/2014/main" id="{7C4EF111-7806-BA1B-D4C5-1E9B1C3BA90C}"/>
               </a:ext>
             </a:extLst>
           </p:cNvPr>
@@ -9633,7 +9633,7 @@
           <p:cNvPr id="16" name="source">
             <a:extLst>
               <a:ext uri="{FF2B5EF4-FFF2-40B4-BE49-F238E27FC236}">
-                <a16:creationId xmlns:a16="http://schemas.microsoft.com/office/drawing/2014/main" id="{1C3DBE20-B046-EF84-7936-6E5751D6B4D3}"/>
+                <a16:creationId xmlns:a16="http://schemas.microsoft.com/office/drawing/2014/main" id="{2F62CD35-2127-7B7B-BBE5-1C56A17D26E6}"/>
               </a:ext>
             </a:extLst>
           </p:cNvPr>
@@ -9688,7 +9688,7 @@
     </p:spTree>
     <p:extLst>
       <p:ext uri="{BB962C8B-B14F-4D97-AF65-F5344CB8AC3E}">
-        <p14:creationId xmlns:p14="http://schemas.microsoft.com/office/powerpoint/2010/main" val="1672818116"/>
+        <p14:creationId xmlns:p14="http://schemas.microsoft.com/office/powerpoint/2010/main" val="3004765596"/>
       </p:ext>
     </p:extLst>
   </p:cSld>
@@ -9720,7 +9720,7 @@
           <p:cNvPr id="7" name="creative_background">
             <a:extLst>
               <a:ext uri="{FF2B5EF4-FFF2-40B4-BE49-F238E27FC236}">
-                <a16:creationId xmlns:a16="http://schemas.microsoft.com/office/drawing/2014/main" id="{8DADA1F4-004B-48AE-4356-D2F624F9346C}"/>
+                <a16:creationId xmlns:a16="http://schemas.microsoft.com/office/drawing/2014/main" id="{51AB1D51-FC4F-85AD-3E37-86FAC5A30AC9}"/>
               </a:ext>
             </a:extLst>
           </p:cNvPr>
@@ -9793,7 +9793,7 @@
           <a:bodyPr/>
           <a:lstStyle/>
           <a:p>
-            <a:fld id="{DA01C8C9-DA9E-4EB0-8756-652B0DE35A87}" type="datetimeFigureOut">
+            <a:fld id="{4E307407-BF02-4185-B795-8EFF67E65125}" type="datetimeFigureOut">
               <a:rPr lang="en-US" smtClean="0"/>
               <a:t>10/3/2026</a:t>
             </a:fld>
@@ -9835,7 +9835,7 @@
           <a:bodyPr/>
           <a:lstStyle/>
           <a:p>
-            <a:fld id="{E8DEFA18-2CFA-4775-9ECD-212CDF18C33F}" type="slidenum">
+            <a:fld id="{0901BA54-D28A-46F7-BDED-B9CC383D9A66}" type="slidenum">
               <a:rPr lang="en-US" smtClean="0"/>
               <a:t>‹#›</a:t>
             </a:fld>
@@ -9848,7 +9848,7 @@
           <p:cNvPr id="8" name="decisions_title">
             <a:extLst>
               <a:ext uri="{FF2B5EF4-FFF2-40B4-BE49-F238E27FC236}">
-                <a16:creationId xmlns:a16="http://schemas.microsoft.com/office/drawing/2014/main" id="{98CA5DAF-27D0-D47F-50C1-F2E15A187EA2}"/>
+                <a16:creationId xmlns:a16="http://schemas.microsoft.com/office/drawing/2014/main" id="{09F067E2-C427-9284-28A0-0F62F0C372BD}"/>
               </a:ext>
             </a:extLst>
           </p:cNvPr>
@@ -9898,7 +9898,7 @@
           <p:cNvPr id="9" name="decisions">
             <a:extLst>
               <a:ext uri="{FF2B5EF4-FFF2-40B4-BE49-F238E27FC236}">
-                <a16:creationId xmlns:a16="http://schemas.microsoft.com/office/drawing/2014/main" id="{708A7B3C-DADA-D59A-85EB-EE8A0E2D67C6}"/>
+                <a16:creationId xmlns:a16="http://schemas.microsoft.com/office/drawing/2014/main" id="{812BCF3D-3350-3F24-1C94-E9978E2F3DF5}"/>
               </a:ext>
             </a:extLst>
           </p:cNvPr>
@@ -9941,7 +9941,7 @@
           <p:cNvPr id="10" name="item_1_title">
             <a:extLst>
               <a:ext uri="{FF2B5EF4-FFF2-40B4-BE49-F238E27FC236}">
-                <a16:creationId xmlns:a16="http://schemas.microsoft.com/office/drawing/2014/main" id="{C977F360-5E77-0DF4-0E30-990DC1457BD2}"/>
+                <a16:creationId xmlns:a16="http://schemas.microsoft.com/office/drawing/2014/main" id="{719F1010-EA84-1FB0-E454-E63DA4513845}"/>
               </a:ext>
             </a:extLst>
           </p:cNvPr>
@@ -9994,7 +9994,7 @@
           <p:cNvPr id="11" name="item_1">
             <a:extLst>
               <a:ext uri="{FF2B5EF4-FFF2-40B4-BE49-F238E27FC236}">
-                <a16:creationId xmlns:a16="http://schemas.microsoft.com/office/drawing/2014/main" id="{34F696D7-54E1-A873-CD96-83D4082AE50F}"/>
+                <a16:creationId xmlns:a16="http://schemas.microsoft.com/office/drawing/2014/main" id="{5B68A94F-A082-1238-2501-CDE1C6F9ACB9}"/>
               </a:ext>
             </a:extLst>
           </p:cNvPr>
@@ -10042,7 +10042,7 @@
           <p:cNvPr id="12" name="item_2_title">
             <a:extLst>
               <a:ext uri="{FF2B5EF4-FFF2-40B4-BE49-F238E27FC236}">
-                <a16:creationId xmlns:a16="http://schemas.microsoft.com/office/drawing/2014/main" id="{5C516EFF-3BC0-CD22-1754-5B30DEB40C62}"/>
+                <a16:creationId xmlns:a16="http://schemas.microsoft.com/office/drawing/2014/main" id="{EF10CC02-834A-71F9-7540-66B59FD84A8D}"/>
               </a:ext>
             </a:extLst>
           </p:cNvPr>
@@ -10095,7 +10095,7 @@
           <p:cNvPr id="13" name="item_2">
             <a:extLst>
               <a:ext uri="{FF2B5EF4-FFF2-40B4-BE49-F238E27FC236}">
-                <a16:creationId xmlns:a16="http://schemas.microsoft.com/office/drawing/2014/main" id="{A9470F16-8A53-F2A3-5186-F25DA23856D2}"/>
+                <a16:creationId xmlns:a16="http://schemas.microsoft.com/office/drawing/2014/main" id="{8796C94C-C76D-C91C-6879-539332F1B0DC}"/>
               </a:ext>
             </a:extLst>
           </p:cNvPr>
@@ -10143,7 +10143,7 @@
           <p:cNvPr id="14" name="item_3_title">
             <a:extLst>
               <a:ext uri="{FF2B5EF4-FFF2-40B4-BE49-F238E27FC236}">
-                <a16:creationId xmlns:a16="http://schemas.microsoft.com/office/drawing/2014/main" id="{4B9F4CA2-61BF-2275-2B9B-6AE85EB4F9D7}"/>
+                <a16:creationId xmlns:a16="http://schemas.microsoft.com/office/drawing/2014/main" id="{D1E3DB63-118A-31F2-1531-80E12E97269B}"/>
               </a:ext>
             </a:extLst>
           </p:cNvPr>
@@ -10196,7 +10196,7 @@
           <p:cNvPr id="15" name="item_3">
             <a:extLst>
               <a:ext uri="{FF2B5EF4-FFF2-40B4-BE49-F238E27FC236}">
-                <a16:creationId xmlns:a16="http://schemas.microsoft.com/office/drawing/2014/main" id="{F18EEDEA-03F6-6E5F-6B6F-9C1333D1F866}"/>
+                <a16:creationId xmlns:a16="http://schemas.microsoft.com/office/drawing/2014/main" id="{A87E988A-0176-A5A1-BE97-DAFBEF12650E}"/>
               </a:ext>
             </a:extLst>
           </p:cNvPr>
@@ -10244,7 +10244,7 @@
           <p:cNvPr id="16" name="source">
             <a:extLst>
               <a:ext uri="{FF2B5EF4-FFF2-40B4-BE49-F238E27FC236}">
-                <a16:creationId xmlns:a16="http://schemas.microsoft.com/office/drawing/2014/main" id="{FE9992EB-15C6-5BD5-1AF7-A12E93963535}"/>
+                <a16:creationId xmlns:a16="http://schemas.microsoft.com/office/drawing/2014/main" id="{11CD5AFC-8A26-4D72-B4AE-C558661E6A00}"/>
               </a:ext>
             </a:extLst>
           </p:cNvPr>
@@ -10299,7 +10299,7 @@
     </p:spTree>
     <p:extLst>
       <p:ext uri="{BB962C8B-B14F-4D97-AF65-F5344CB8AC3E}">
-        <p14:creationId xmlns:p14="http://schemas.microsoft.com/office/powerpoint/2010/main" val="29508181"/>
+        <p14:creationId xmlns:p14="http://schemas.microsoft.com/office/powerpoint/2010/main" val="1264411202"/>
       </p:ext>
     </p:extLst>
   </p:cSld>
@@ -10331,7 +10331,7 @@
           <p:cNvPr id="7" name="creative_background">
             <a:extLst>
               <a:ext uri="{FF2B5EF4-FFF2-40B4-BE49-F238E27FC236}">
-                <a16:creationId xmlns:a16="http://schemas.microsoft.com/office/drawing/2014/main" id="{D9A73453-9727-1D7D-C79F-DBBD849AE3D5}"/>
+                <a16:creationId xmlns:a16="http://schemas.microsoft.com/office/drawing/2014/main" id="{A0546772-8105-A1FA-DAB5-5594EA7FB67E}"/>
               </a:ext>
             </a:extLst>
           </p:cNvPr>
@@ -10404,7 +10404,7 @@
           <a:bodyPr/>
           <a:lstStyle/>
           <a:p>
-            <a:fld id="{DA01C8C9-DA9E-4EB0-8756-652B0DE35A87}" type="datetimeFigureOut">
+            <a:fld id="{4E307407-BF02-4185-B795-8EFF67E65125}" type="datetimeFigureOut">
               <a:rPr lang="en-US" smtClean="0"/>
               <a:t>10/3/2026</a:t>
             </a:fld>
@@ -10446,7 +10446,7 @@
           <a:bodyPr/>
           <a:lstStyle/>
           <a:p>
-            <a:fld id="{E8DEFA18-2CFA-4775-9ECD-212CDF18C33F}" type="slidenum">
+            <a:fld id="{0901BA54-D28A-46F7-BDED-B9CC383D9A66}" type="slidenum">
               <a:rPr lang="en-US" smtClean="0"/>
               <a:t>‹#›</a:t>
             </a:fld>
@@ -10459,7 +10459,7 @@
           <p:cNvPr id="8" name="body">
             <a:extLst>
               <a:ext uri="{FF2B5EF4-FFF2-40B4-BE49-F238E27FC236}">
-                <a16:creationId xmlns:a16="http://schemas.microsoft.com/office/drawing/2014/main" id="{0F1C5570-C9E3-694F-C8A3-5FB346B7AF4D}"/>
+                <a16:creationId xmlns:a16="http://schemas.microsoft.com/office/drawing/2014/main" id="{BBC9699B-14C8-4D4D-4824-61FF1DCDFAEC}"/>
               </a:ext>
             </a:extLst>
           </p:cNvPr>
@@ -10499,7 +10499,7 @@
           <p:cNvPr id="9" name="kpi_value_1">
             <a:extLst>
               <a:ext uri="{FF2B5EF4-FFF2-40B4-BE49-F238E27FC236}">
-                <a16:creationId xmlns:a16="http://schemas.microsoft.com/office/drawing/2014/main" id="{26AEC11A-5468-1406-424D-D14D90F40F1D}"/>
+                <a16:creationId xmlns:a16="http://schemas.microsoft.com/office/drawing/2014/main" id="{50BA76BD-7A93-1D0D-E825-06EA188A4BC1}"/>
               </a:ext>
             </a:extLst>
           </p:cNvPr>
@@ -10552,7 +10552,7 @@
           <p:cNvPr id="10" name="kpi_label_1">
             <a:extLst>
               <a:ext uri="{FF2B5EF4-FFF2-40B4-BE49-F238E27FC236}">
-                <a16:creationId xmlns:a16="http://schemas.microsoft.com/office/drawing/2014/main" id="{0BF4B250-8221-2B06-1C3C-1D0920FCC083}"/>
+                <a16:creationId xmlns:a16="http://schemas.microsoft.com/office/drawing/2014/main" id="{11800773-A90A-01ED-C50D-E97BF75F3191}"/>
               </a:ext>
             </a:extLst>
           </p:cNvPr>
@@ -10600,7 +10600,7 @@
           <p:cNvPr id="11" name="kpi_value_2">
             <a:extLst>
               <a:ext uri="{FF2B5EF4-FFF2-40B4-BE49-F238E27FC236}">
-                <a16:creationId xmlns:a16="http://schemas.microsoft.com/office/drawing/2014/main" id="{DB7ADECA-B2F4-C5DD-B9C0-0EA718A8C441}"/>
+                <a16:creationId xmlns:a16="http://schemas.microsoft.com/office/drawing/2014/main" id="{7D4479F1-E376-EF16-4EBE-0679AAAEEF5A}"/>
               </a:ext>
             </a:extLst>
           </p:cNvPr>
@@ -10653,7 +10653,7 @@
           <p:cNvPr id="12" name="kpi_label_2">
             <a:extLst>
               <a:ext uri="{FF2B5EF4-FFF2-40B4-BE49-F238E27FC236}">
-                <a16:creationId xmlns:a16="http://schemas.microsoft.com/office/drawing/2014/main" id="{46298877-4F7B-808B-D879-DC75A23BBBC5}"/>
+                <a16:creationId xmlns:a16="http://schemas.microsoft.com/office/drawing/2014/main" id="{E5AA3C6B-7B1B-E97C-1822-BCC42EE84A54}"/>
               </a:ext>
             </a:extLst>
           </p:cNvPr>
@@ -10701,7 +10701,7 @@
           <p:cNvPr id="13" name="source">
             <a:extLst>
               <a:ext uri="{FF2B5EF4-FFF2-40B4-BE49-F238E27FC236}">
-                <a16:creationId xmlns:a16="http://schemas.microsoft.com/office/drawing/2014/main" id="{D2B4A43C-B14D-0BD4-D232-DAECAE514B16}"/>
+                <a16:creationId xmlns:a16="http://schemas.microsoft.com/office/drawing/2014/main" id="{36330ACE-C8E4-0EBA-60A9-BFF569D9DBA4}"/>
               </a:ext>
             </a:extLst>
           </p:cNvPr>
@@ -10756,7 +10756,7 @@
     </p:spTree>
     <p:extLst>
       <p:ext uri="{BB962C8B-B14F-4D97-AF65-F5344CB8AC3E}">
-        <p14:creationId xmlns:p14="http://schemas.microsoft.com/office/powerpoint/2010/main" val="830758775"/>
+        <p14:creationId xmlns:p14="http://schemas.microsoft.com/office/powerpoint/2010/main" val="542672499"/>
       </p:ext>
     </p:extLst>
   </p:cSld>
@@ -10788,7 +10788,7 @@
           <p:cNvPr id="7" name="creative_background">
             <a:extLst>
               <a:ext uri="{FF2B5EF4-FFF2-40B4-BE49-F238E27FC236}">
-                <a16:creationId xmlns:a16="http://schemas.microsoft.com/office/drawing/2014/main" id="{E0D49289-628E-888D-A83F-8D9D88A646E6}"/>
+                <a16:creationId xmlns:a16="http://schemas.microsoft.com/office/drawing/2014/main" id="{DD258CCE-B61D-D2A1-E199-0AA7BA8672B6}"/>
               </a:ext>
             </a:extLst>
           </p:cNvPr>
@@ -10861,7 +10861,7 @@
           <a:bodyPr/>
           <a:lstStyle/>
           <a:p>
-            <a:fld id="{DA01C8C9-DA9E-4EB0-8756-652B0DE35A87}" type="datetimeFigureOut">
+            <a:fld id="{4E307407-BF02-4185-B795-8EFF67E65125}" type="datetimeFigureOut">
               <a:rPr lang="en-US" smtClean="0"/>
               <a:t>10/3/2026</a:t>
             </a:fld>
@@ -10903,7 +10903,7 @@
           <a:bodyPr/>
           <a:lstStyle/>
           <a:p>
-            <a:fld id="{E8DEFA18-2CFA-4775-9ECD-212CDF18C33F}" type="slidenum">
+            <a:fld id="{0901BA54-D28A-46F7-BDED-B9CC383D9A66}" type="slidenum">
               <a:rPr lang="en-US" smtClean="0"/>
               <a:t>‹#›</a:t>
             </a:fld>
@@ -10916,7 +10916,7 @@
           <p:cNvPr id="8" name="body">
             <a:extLst>
               <a:ext uri="{FF2B5EF4-FFF2-40B4-BE49-F238E27FC236}">
-                <a16:creationId xmlns:a16="http://schemas.microsoft.com/office/drawing/2014/main" id="{BC6597FD-6B92-2EE0-E5D9-D8708CC3F0B7}"/>
+                <a16:creationId xmlns:a16="http://schemas.microsoft.com/office/drawing/2014/main" id="{8F476CD1-EC22-8AAC-1445-5E439291F105}"/>
               </a:ext>
             </a:extLst>
           </p:cNvPr>
@@ -10956,7 +10956,7 @@
           <p:cNvPr id="9" name="kpi_value_1">
             <a:extLst>
               <a:ext uri="{FF2B5EF4-FFF2-40B4-BE49-F238E27FC236}">
-                <a16:creationId xmlns:a16="http://schemas.microsoft.com/office/drawing/2014/main" id="{C4752A04-5777-B7DC-C7B6-C6D79721D990}"/>
+                <a16:creationId xmlns:a16="http://schemas.microsoft.com/office/drawing/2014/main" id="{48743C46-9F13-9291-07B7-6842989808A4}"/>
               </a:ext>
             </a:extLst>
           </p:cNvPr>
@@ -11009,7 +11009,7 @@
           <p:cNvPr id="10" name="kpi_label_1">
             <a:extLst>
               <a:ext uri="{FF2B5EF4-FFF2-40B4-BE49-F238E27FC236}">
-                <a16:creationId xmlns:a16="http://schemas.microsoft.com/office/drawing/2014/main" id="{8B3CDF03-9D19-E7A4-C195-4F9717DE4FFA}"/>
+                <a16:creationId xmlns:a16="http://schemas.microsoft.com/office/drawing/2014/main" id="{F5E9180B-673C-4CAA-E4FD-7A139A8CAEB2}"/>
               </a:ext>
             </a:extLst>
           </p:cNvPr>
@@ -11057,7 +11057,7 @@
           <p:cNvPr id="11" name="kpi_value_2">
             <a:extLst>
               <a:ext uri="{FF2B5EF4-FFF2-40B4-BE49-F238E27FC236}">
-                <a16:creationId xmlns:a16="http://schemas.microsoft.com/office/drawing/2014/main" id="{6D8B81AD-0642-EECE-996A-4E9278E50DC2}"/>
+                <a16:creationId xmlns:a16="http://schemas.microsoft.com/office/drawing/2014/main" id="{E5F4E1C7-24E5-392B-19A8-5A8F8ED69121}"/>
               </a:ext>
             </a:extLst>
           </p:cNvPr>
@@ -11110,7 +11110,7 @@
           <p:cNvPr id="12" name="kpi_label_2">
             <a:extLst>
               <a:ext uri="{FF2B5EF4-FFF2-40B4-BE49-F238E27FC236}">
-                <a16:creationId xmlns:a16="http://schemas.microsoft.com/office/drawing/2014/main" id="{5D117386-F8F7-7C22-950B-B203C8DF26CA}"/>
+                <a16:creationId xmlns:a16="http://schemas.microsoft.com/office/drawing/2014/main" id="{47ACF9E1-7254-322A-EBAF-E8536818AE94}"/>
               </a:ext>
             </a:extLst>
           </p:cNvPr>
@@ -11158,7 +11158,7 @@
           <p:cNvPr id="13" name="kpi_value_3">
             <a:extLst>
               <a:ext uri="{FF2B5EF4-FFF2-40B4-BE49-F238E27FC236}">
-                <a16:creationId xmlns:a16="http://schemas.microsoft.com/office/drawing/2014/main" id="{AADABB3E-5153-5EA9-199A-2FF02DA0CAF3}"/>
+                <a16:creationId xmlns:a16="http://schemas.microsoft.com/office/drawing/2014/main" id="{CED03129-C47B-2B08-C96B-CC8D1B918F0D}"/>
               </a:ext>
             </a:extLst>
           </p:cNvPr>
@@ -11211,7 +11211,7 @@
           <p:cNvPr id="14" name="kpi_label_3">
             <a:extLst>
               <a:ext uri="{FF2B5EF4-FFF2-40B4-BE49-F238E27FC236}">
-                <a16:creationId xmlns:a16="http://schemas.microsoft.com/office/drawing/2014/main" id="{B833A34B-B153-7D40-A57F-64514D9684C5}"/>
+                <a16:creationId xmlns:a16="http://schemas.microsoft.com/office/drawing/2014/main" id="{F28DAC2B-7B71-F7AC-8C2B-AD317EAFFDFA}"/>
               </a:ext>
             </a:extLst>
           </p:cNvPr>
@@ -11259,7 +11259,7 @@
           <p:cNvPr id="15" name="kpi_value_4">
             <a:extLst>
               <a:ext uri="{FF2B5EF4-FFF2-40B4-BE49-F238E27FC236}">
-                <a16:creationId xmlns:a16="http://schemas.microsoft.com/office/drawing/2014/main" id="{425A5949-7367-9FEB-48A3-9468CECC2123}"/>
+                <a16:creationId xmlns:a16="http://schemas.microsoft.com/office/drawing/2014/main" id="{7E87ECD0-9011-6457-1017-8366F9CF88C2}"/>
               </a:ext>
             </a:extLst>
           </p:cNvPr>
@@ -11312,7 +11312,7 @@
           <p:cNvPr id="16" name="kpi_label_4">
             <a:extLst>
               <a:ext uri="{FF2B5EF4-FFF2-40B4-BE49-F238E27FC236}">
-                <a16:creationId xmlns:a16="http://schemas.microsoft.com/office/drawing/2014/main" id="{32EC2B71-18A7-2DEB-902B-95B07C872B8C}"/>
+                <a16:creationId xmlns:a16="http://schemas.microsoft.com/office/drawing/2014/main" id="{EEDECB4A-BEEA-C45A-4D2A-70E1265E015B}"/>
               </a:ext>
             </a:extLst>
           </p:cNvPr>
@@ -11360,7 +11360,7 @@
           <p:cNvPr id="17" name="source">
             <a:extLst>
               <a:ext uri="{FF2B5EF4-FFF2-40B4-BE49-F238E27FC236}">
-                <a16:creationId xmlns:a16="http://schemas.microsoft.com/office/drawing/2014/main" id="{C9A65ECA-0304-091B-C3A1-24DE8ECB338F}"/>
+                <a16:creationId xmlns:a16="http://schemas.microsoft.com/office/drawing/2014/main" id="{CD29401F-FF1A-9A30-A9A5-D6779473D77C}"/>
               </a:ext>
             </a:extLst>
           </p:cNvPr>
@@ -11415,7 +11415,7 @@
     </p:spTree>
     <p:extLst>
       <p:ext uri="{BB962C8B-B14F-4D97-AF65-F5344CB8AC3E}">
-        <p14:creationId xmlns:p14="http://schemas.microsoft.com/office/powerpoint/2010/main" val="1251675358"/>
+        <p14:creationId xmlns:p14="http://schemas.microsoft.com/office/powerpoint/2010/main" val="2127349725"/>
       </p:ext>
     </p:extLst>
   </p:cSld>
@@ -11447,7 +11447,7 @@
           <p:cNvPr id="7" name="creative_background">
             <a:extLst>
               <a:ext uri="{FF2B5EF4-FFF2-40B4-BE49-F238E27FC236}">
-                <a16:creationId xmlns:a16="http://schemas.microsoft.com/office/drawing/2014/main" id="{CF0B87C2-00F3-EB38-9EB0-7FD2B716BA15}"/>
+                <a16:creationId xmlns:a16="http://schemas.microsoft.com/office/drawing/2014/main" id="{4E84F78B-FC3D-9C10-0BEE-94FB842CB012}"/>
               </a:ext>
             </a:extLst>
           </p:cNvPr>
@@ -11520,7 +11520,7 @@
           <a:bodyPr/>
           <a:lstStyle/>
           <a:p>
-            <a:fld id="{DA01C8C9-DA9E-4EB0-8756-652B0DE35A87}" type="datetimeFigureOut">
+            <a:fld id="{4E307407-BF02-4185-B795-8EFF67E65125}" type="datetimeFigureOut">
               <a:rPr lang="en-US" smtClean="0"/>
               <a:t>10/3/2026</a:t>
             </a:fld>
@@ -11562,7 +11562,7 @@
           <a:bodyPr/>
           <a:lstStyle/>
           <a:p>
-            <a:fld id="{E8DEFA18-2CFA-4775-9ECD-212CDF18C33F}" type="slidenum">
+            <a:fld id="{0901BA54-D28A-46F7-BDED-B9CC383D9A66}" type="slidenum">
               <a:rPr lang="en-US" smtClean="0"/>
               <a:t>‹#›</a:t>
             </a:fld>
@@ -11575,7 +11575,7 @@
           <p:cNvPr id="8" name="body">
             <a:extLst>
               <a:ext uri="{FF2B5EF4-FFF2-40B4-BE49-F238E27FC236}">
-                <a16:creationId xmlns:a16="http://schemas.microsoft.com/office/drawing/2014/main" id="{C24A2BEA-EB29-85AF-3BA7-0E0E678FA8D2}"/>
+                <a16:creationId xmlns:a16="http://schemas.microsoft.com/office/drawing/2014/main" id="{880F5AB1-B825-B09C-69E5-45AF91B94A53}"/>
               </a:ext>
             </a:extLst>
           </p:cNvPr>
@@ -11615,7 +11615,7 @@
           <p:cNvPr id="9" name="quote">
             <a:extLst>
               <a:ext uri="{FF2B5EF4-FFF2-40B4-BE49-F238E27FC236}">
-                <a16:creationId xmlns:a16="http://schemas.microsoft.com/office/drawing/2014/main" id="{442F2E3B-8544-402F-2A25-1A3187A859E3}"/>
+                <a16:creationId xmlns:a16="http://schemas.microsoft.com/office/drawing/2014/main" id="{46C318A9-D403-5930-A602-F92FCB20656E}"/>
               </a:ext>
             </a:extLst>
           </p:cNvPr>
@@ -11665,7 +11665,7 @@
           <p:cNvPr id="10" name="attribution">
             <a:extLst>
               <a:ext uri="{FF2B5EF4-FFF2-40B4-BE49-F238E27FC236}">
-                <a16:creationId xmlns:a16="http://schemas.microsoft.com/office/drawing/2014/main" id="{2ADBFE02-417E-1816-E42A-DE2BD6C520EC}"/>
+                <a16:creationId xmlns:a16="http://schemas.microsoft.com/office/drawing/2014/main" id="{167EB4FB-9E62-D666-D0F9-D7B9AD4388D7}"/>
               </a:ext>
             </a:extLst>
           </p:cNvPr>
@@ -11713,7 +11713,7 @@
           <p:cNvPr id="11" name="source">
             <a:extLst>
               <a:ext uri="{FF2B5EF4-FFF2-40B4-BE49-F238E27FC236}">
-                <a16:creationId xmlns:a16="http://schemas.microsoft.com/office/drawing/2014/main" id="{6B16F82D-FC58-14AE-0F4A-D684877B84C1}"/>
+                <a16:creationId xmlns:a16="http://schemas.microsoft.com/office/drawing/2014/main" id="{BCC17E40-B7AD-4F4D-5DFB-897B3B67BD01}"/>
               </a:ext>
             </a:extLst>
           </p:cNvPr>
@@ -11768,7 +11768,7 @@
     </p:spTree>
     <p:extLst>
       <p:ext uri="{BB962C8B-B14F-4D97-AF65-F5344CB8AC3E}">
-        <p14:creationId xmlns:p14="http://schemas.microsoft.com/office/powerpoint/2010/main" val="801830744"/>
+        <p14:creationId xmlns:p14="http://schemas.microsoft.com/office/powerpoint/2010/main" val="3225181309"/>
       </p:ext>
     </p:extLst>
   </p:cSld>
@@ -11800,7 +11800,7 @@
           <p:cNvPr id="7" name="creative_background">
             <a:extLst>
               <a:ext uri="{FF2B5EF4-FFF2-40B4-BE49-F238E27FC236}">
-                <a16:creationId xmlns:a16="http://schemas.microsoft.com/office/drawing/2014/main" id="{70E34E1A-847A-1A4C-252A-942DF3FD55E8}"/>
+                <a16:creationId xmlns:a16="http://schemas.microsoft.com/office/drawing/2014/main" id="{BA56260D-5DF8-963F-61A3-97768CFC3D7C}"/>
               </a:ext>
             </a:extLst>
           </p:cNvPr>
@@ -11873,7 +11873,7 @@
           <a:bodyPr/>
           <a:lstStyle/>
           <a:p>
-            <a:fld id="{DA01C8C9-DA9E-4EB0-8756-652B0DE35A87}" type="datetimeFigureOut">
+            <a:fld id="{4E307407-BF02-4185-B795-8EFF67E65125}" type="datetimeFigureOut">
               <a:rPr lang="en-US" smtClean="0"/>
               <a:t>10/3/2026</a:t>
             </a:fld>
@@ -11915,7 +11915,7 @@
           <a:bodyPr/>
           <a:lstStyle/>
           <a:p>
-            <a:fld id="{E8DEFA18-2CFA-4775-9ECD-212CDF18C33F}" type="slidenum">
+            <a:fld id="{0901BA54-D28A-46F7-BDED-B9CC383D9A66}" type="slidenum">
               <a:rPr lang="en-US" smtClean="0"/>
               <a:t>‹#›</a:t>
             </a:fld>
@@ -11928,7 +11928,7 @@
           <p:cNvPr id="8" name="item_1_title">
             <a:extLst>
               <a:ext uri="{FF2B5EF4-FFF2-40B4-BE49-F238E27FC236}">
-                <a16:creationId xmlns:a16="http://schemas.microsoft.com/office/drawing/2014/main" id="{60353FAD-A90D-1FD2-47DD-F74E82CC32C9}"/>
+                <a16:creationId xmlns:a16="http://schemas.microsoft.com/office/drawing/2014/main" id="{1C12CC33-0BA2-98E2-9185-75E127FFF245}"/>
               </a:ext>
             </a:extLst>
           </p:cNvPr>
@@ -11978,7 +11978,7 @@
           <p:cNvPr id="9" name="item_1">
             <a:extLst>
               <a:ext uri="{FF2B5EF4-FFF2-40B4-BE49-F238E27FC236}">
-                <a16:creationId xmlns:a16="http://schemas.microsoft.com/office/drawing/2014/main" id="{412F8EEC-A179-FC13-D442-565ABDFC52B2}"/>
+                <a16:creationId xmlns:a16="http://schemas.microsoft.com/office/drawing/2014/main" id="{A3E352A6-D1FC-8560-37F0-0F1A23DAAADB}"/>
               </a:ext>
             </a:extLst>
           </p:cNvPr>
@@ -12026,7 +12026,7 @@
           <p:cNvPr id="10" name="item_2_title">
             <a:extLst>
               <a:ext uri="{FF2B5EF4-FFF2-40B4-BE49-F238E27FC236}">
-                <a16:creationId xmlns:a16="http://schemas.microsoft.com/office/drawing/2014/main" id="{84F5B641-1CF0-4518-7C23-F4F962541B42}"/>
+                <a16:creationId xmlns:a16="http://schemas.microsoft.com/office/drawing/2014/main" id="{A06083D5-1235-4FB9-7C67-F3C1D890AFA7}"/>
               </a:ext>
             </a:extLst>
           </p:cNvPr>
@@ -12079,7 +12079,7 @@
           <p:cNvPr id="11" name="item_2">
             <a:extLst>
               <a:ext uri="{FF2B5EF4-FFF2-40B4-BE49-F238E27FC236}">
-                <a16:creationId xmlns:a16="http://schemas.microsoft.com/office/drawing/2014/main" id="{2B70F4EE-C050-8B18-9F71-212F3CA84DE5}"/>
+                <a16:creationId xmlns:a16="http://schemas.microsoft.com/office/drawing/2014/main" id="{E1B01F3E-0B64-9EFE-CBF2-715C6C47DBCC}"/>
               </a:ext>
             </a:extLst>
           </p:cNvPr>
@@ -12127,7 +12127,7 @@
           <p:cNvPr id="12" name="item_3_title">
             <a:extLst>
               <a:ext uri="{FF2B5EF4-FFF2-40B4-BE49-F238E27FC236}">
-                <a16:creationId xmlns:a16="http://schemas.microsoft.com/office/drawing/2014/main" id="{223090D2-ABBB-98D1-3664-AC1531F30EEB}"/>
+                <a16:creationId xmlns:a16="http://schemas.microsoft.com/office/drawing/2014/main" id="{532B24C7-E6DF-8903-C18F-F77C5B472505}"/>
               </a:ext>
             </a:extLst>
           </p:cNvPr>
@@ -12180,7 +12180,7 @@
           <p:cNvPr id="13" name="item_3">
             <a:extLst>
               <a:ext uri="{FF2B5EF4-FFF2-40B4-BE49-F238E27FC236}">
-                <a16:creationId xmlns:a16="http://schemas.microsoft.com/office/drawing/2014/main" id="{D9B68798-039D-D938-09C3-A9A14AACCD2B}"/>
+                <a16:creationId xmlns:a16="http://schemas.microsoft.com/office/drawing/2014/main" id="{4D7861D9-F2CB-0FEB-0207-8618CF440131}"/>
               </a:ext>
             </a:extLst>
           </p:cNvPr>
@@ -12228,7 +12228,7 @@
           <p:cNvPr id="14" name="source">
             <a:extLst>
               <a:ext uri="{FF2B5EF4-FFF2-40B4-BE49-F238E27FC236}">
-                <a16:creationId xmlns:a16="http://schemas.microsoft.com/office/drawing/2014/main" id="{06101F6B-A7D1-7DAB-498A-6DA84B56FE77}"/>
+                <a16:creationId xmlns:a16="http://schemas.microsoft.com/office/drawing/2014/main" id="{C1F27B46-0574-CDA3-0BC6-A70DFEAB2B1B}"/>
               </a:ext>
             </a:extLst>
           </p:cNvPr>
@@ -12283,7 +12283,7 @@
     </p:spTree>
     <p:extLst>
       <p:ext uri="{BB962C8B-B14F-4D97-AF65-F5344CB8AC3E}">
-        <p14:creationId xmlns:p14="http://schemas.microsoft.com/office/powerpoint/2010/main" val="2891921141"/>
+        <p14:creationId xmlns:p14="http://schemas.microsoft.com/office/powerpoint/2010/main" val="4247467791"/>
       </p:ext>
     </p:extLst>
   </p:cSld>
@@ -12315,7 +12315,7 @@
           <p:cNvPr id="7" name="creative_background">
             <a:extLst>
               <a:ext uri="{FF2B5EF4-FFF2-40B4-BE49-F238E27FC236}">
-                <a16:creationId xmlns:a16="http://schemas.microsoft.com/office/drawing/2014/main" id="{001155CA-0881-E787-D112-332E27A92028}"/>
+                <a16:creationId xmlns:a16="http://schemas.microsoft.com/office/drawing/2014/main" id="{87BE3484-E927-A64A-61AC-948A80FFEABA}"/>
               </a:ext>
             </a:extLst>
           </p:cNvPr>
@@ -12388,7 +12388,7 @@
           <a:bodyPr/>
           <a:lstStyle/>
           <a:p>
-            <a:fld id="{DA01C8C9-DA9E-4EB0-8756-652B0DE35A87}" type="datetimeFigureOut">
+            <a:fld id="{4E307407-BF02-4185-B795-8EFF67E65125}" type="datetimeFigureOut">
               <a:rPr lang="en-US" smtClean="0"/>
               <a:t>10/3/2026</a:t>
             </a:fld>
@@ -12430,7 +12430,7 @@
           <a:bodyPr/>
           <a:lstStyle/>
           <a:p>
-            <a:fld id="{E8DEFA18-2CFA-4775-9ECD-212CDF18C33F}" type="slidenum">
+            <a:fld id="{0901BA54-D28A-46F7-BDED-B9CC383D9A66}" type="slidenum">
               <a:rPr lang="en-US" smtClean="0"/>
               <a:t>‹#›</a:t>
             </a:fld>
@@ -12443,7 +12443,7 @@
           <p:cNvPr id="8" name="item_1_title">
             <a:extLst>
               <a:ext uri="{FF2B5EF4-FFF2-40B4-BE49-F238E27FC236}">
-                <a16:creationId xmlns:a16="http://schemas.microsoft.com/office/drawing/2014/main" id="{A5801E20-9AC7-88A9-B084-5D56298ECE5C}"/>
+                <a16:creationId xmlns:a16="http://schemas.microsoft.com/office/drawing/2014/main" id="{8571A8A7-E11D-92F1-DD07-F11C3B0D4BB1}"/>
               </a:ext>
             </a:extLst>
           </p:cNvPr>
@@ -12493,7 +12493,7 @@
           <p:cNvPr id="9" name="item_1">
             <a:extLst>
               <a:ext uri="{FF2B5EF4-FFF2-40B4-BE49-F238E27FC236}">
-                <a16:creationId xmlns:a16="http://schemas.microsoft.com/office/drawing/2014/main" id="{7830350D-2164-5D11-196E-5B788093EB2E}"/>
+                <a16:creationId xmlns:a16="http://schemas.microsoft.com/office/drawing/2014/main" id="{2D0F601C-2E37-28B4-D2CB-D4F8D9B6ECC7}"/>
               </a:ext>
             </a:extLst>
           </p:cNvPr>
@@ -12541,7 +12541,7 @@
           <p:cNvPr id="10" name="item_2_title">
             <a:extLst>
               <a:ext uri="{FF2B5EF4-FFF2-40B4-BE49-F238E27FC236}">
-                <a16:creationId xmlns:a16="http://schemas.microsoft.com/office/drawing/2014/main" id="{A607BAB4-83FA-020C-22D5-B9233AE8087C}"/>
+                <a16:creationId xmlns:a16="http://schemas.microsoft.com/office/drawing/2014/main" id="{5CBBD8F3-AF30-02CA-4A3A-0A152CDB01A2}"/>
               </a:ext>
             </a:extLst>
           </p:cNvPr>
@@ -12594,7 +12594,7 @@
           <p:cNvPr id="11" name="item_2">
             <a:extLst>
               <a:ext uri="{FF2B5EF4-FFF2-40B4-BE49-F238E27FC236}">
-                <a16:creationId xmlns:a16="http://schemas.microsoft.com/office/drawing/2014/main" id="{05DE6FE6-EB72-ABD0-301F-00F82ACD90DF}"/>
+                <a16:creationId xmlns:a16="http://schemas.microsoft.com/office/drawing/2014/main" id="{3610A8CB-808C-FDB3-CB83-7244D1B6302F}"/>
               </a:ext>
             </a:extLst>
           </p:cNvPr>
@@ -12642,7 +12642,7 @@
           <p:cNvPr id="12" name="source">
             <a:extLst>
               <a:ext uri="{FF2B5EF4-FFF2-40B4-BE49-F238E27FC236}">
-                <a16:creationId xmlns:a16="http://schemas.microsoft.com/office/drawing/2014/main" id="{BE271034-64F4-D561-6FE7-830E5B25C06E}"/>
+                <a16:creationId xmlns:a16="http://schemas.microsoft.com/office/drawing/2014/main" id="{9958F38B-E81D-045D-5385-BF2E87C50587}"/>
               </a:ext>
             </a:extLst>
           </p:cNvPr>
@@ -12697,7 +12697,7 @@
     </p:spTree>
     <p:extLst>
       <p:ext uri="{BB962C8B-B14F-4D97-AF65-F5344CB8AC3E}">
-        <p14:creationId xmlns:p14="http://schemas.microsoft.com/office/powerpoint/2010/main" val="2326075003"/>
+        <p14:creationId xmlns:p14="http://schemas.microsoft.com/office/powerpoint/2010/main" val="1498136423"/>
       </p:ext>
     </p:extLst>
   </p:cSld>
@@ -12729,7 +12729,7 @@
           <p:cNvPr id="7" name="creative_background">
             <a:extLst>
               <a:ext uri="{FF2B5EF4-FFF2-40B4-BE49-F238E27FC236}">
-                <a16:creationId xmlns:a16="http://schemas.microsoft.com/office/drawing/2014/main" id="{99BBF680-1BE4-4E4A-79C9-14C8C2819AFA}"/>
+                <a16:creationId xmlns:a16="http://schemas.microsoft.com/office/drawing/2014/main" id="{40DF7B42-039A-5373-63A7-00C121AEF124}"/>
               </a:ext>
             </a:extLst>
           </p:cNvPr>
@@ -12802,7 +12802,7 @@
           <a:bodyPr/>
           <a:lstStyle/>
           <a:p>
-            <a:fld id="{DA01C8C9-DA9E-4EB0-8756-652B0DE35A87}" type="datetimeFigureOut">
+            <a:fld id="{4E307407-BF02-4185-B795-8EFF67E65125}" type="datetimeFigureOut">
               <a:rPr lang="en-US" smtClean="0"/>
               <a:t>10/3/2026</a:t>
             </a:fld>
@@ -12844,7 +12844,7 @@
           <a:bodyPr/>
           <a:lstStyle/>
           <a:p>
-            <a:fld id="{E8DEFA18-2CFA-4775-9ECD-212CDF18C33F}" type="slidenum">
+            <a:fld id="{0901BA54-D28A-46F7-BDED-B9CC383D9A66}" type="slidenum">
               <a:rPr lang="en-US" smtClean="0"/>
               <a:t>‹#›</a:t>
             </a:fld>
@@ -12857,7 +12857,7 @@
           <p:cNvPr id="8" name="chart">
             <a:extLst>
               <a:ext uri="{FF2B5EF4-FFF2-40B4-BE49-F238E27FC236}">
-                <a16:creationId xmlns:a16="http://schemas.microsoft.com/office/drawing/2014/main" id="{102C3480-08E6-7024-0A75-CDB4FF8219D0}"/>
+                <a16:creationId xmlns:a16="http://schemas.microsoft.com/office/drawing/2014/main" id="{B6686BE7-881B-3883-EE6C-71992D5FC2D5}"/>
               </a:ext>
             </a:extLst>
           </p:cNvPr>
@@ -12887,7 +12887,7 @@
           <p:cNvPr id="9" name="body">
             <a:extLst>
               <a:ext uri="{FF2B5EF4-FFF2-40B4-BE49-F238E27FC236}">
-                <a16:creationId xmlns:a16="http://schemas.microsoft.com/office/drawing/2014/main" id="{F2384D08-3C79-DB7A-D6AE-C8A85D7E6B86}"/>
+                <a16:creationId xmlns:a16="http://schemas.microsoft.com/office/drawing/2014/main" id="{74FEDEFA-16A5-AAA5-3948-9D1FDEE7F160}"/>
               </a:ext>
             </a:extLst>
           </p:cNvPr>
@@ -12930,7 +12930,7 @@
           <p:cNvPr id="10" name="source">
             <a:extLst>
               <a:ext uri="{FF2B5EF4-FFF2-40B4-BE49-F238E27FC236}">
-                <a16:creationId xmlns:a16="http://schemas.microsoft.com/office/drawing/2014/main" id="{FCAE52D2-1D6B-FE0F-08AD-D4903EEB4246}"/>
+                <a16:creationId xmlns:a16="http://schemas.microsoft.com/office/drawing/2014/main" id="{440D7ACD-668C-D94F-831F-24EE8005F3CA}"/>
               </a:ext>
             </a:extLst>
           </p:cNvPr>
@@ -12985,7 +12985,7 @@
     </p:spTree>
     <p:extLst>
       <p:ext uri="{BB962C8B-B14F-4D97-AF65-F5344CB8AC3E}">
-        <p14:creationId xmlns:p14="http://schemas.microsoft.com/office/powerpoint/2010/main" val="4050568235"/>
+        <p14:creationId xmlns:p14="http://schemas.microsoft.com/office/powerpoint/2010/main" val="1116614177"/>
       </p:ext>
     </p:extLst>
   </p:cSld>
@@ -13017,7 +13017,7 @@
           <p:cNvPr id="7" name="creative_background">
             <a:extLst>
               <a:ext uri="{FF2B5EF4-FFF2-40B4-BE49-F238E27FC236}">
-                <a16:creationId xmlns:a16="http://schemas.microsoft.com/office/drawing/2014/main" id="{23AC2768-C1B6-1618-9DFD-66DAD89DBFB8}"/>
+                <a16:creationId xmlns:a16="http://schemas.microsoft.com/office/drawing/2014/main" id="{64F76FD7-99CA-2B34-A789-27B94DBC1A20}"/>
               </a:ext>
             </a:extLst>
           </p:cNvPr>
@@ -13090,7 +13090,7 @@
           <a:bodyPr/>
           <a:lstStyle/>
           <a:p>
-            <a:fld id="{DA01C8C9-DA9E-4EB0-8756-652B0DE35A87}" type="datetimeFigureOut">
+            <a:fld id="{4E307407-BF02-4185-B795-8EFF67E65125}" type="datetimeFigureOut">
               <a:rPr lang="en-US" smtClean="0"/>
               <a:t>10/3/2026</a:t>
             </a:fld>
@@ -13132,7 +13132,7 @@
           <a:bodyPr/>
           <a:lstStyle/>
           <a:p>
-            <a:fld id="{E8DEFA18-2CFA-4775-9ECD-212CDF18C33F}" type="slidenum">
+            <a:fld id="{0901BA54-D28A-46F7-BDED-B9CC383D9A66}" type="slidenum">
               <a:rPr lang="en-US" smtClean="0"/>
               <a:t>‹#›</a:t>
             </a:fld>
@@ -13145,7 +13145,7 @@
           <p:cNvPr id="8" name="item_1_title">
             <a:extLst>
               <a:ext uri="{FF2B5EF4-FFF2-40B4-BE49-F238E27FC236}">
-                <a16:creationId xmlns:a16="http://schemas.microsoft.com/office/drawing/2014/main" id="{C3DC4040-AA35-8B23-AF3B-48EF6415BFFB}"/>
+                <a16:creationId xmlns:a16="http://schemas.microsoft.com/office/drawing/2014/main" id="{E5273ECE-59B0-E497-1F37-F312E397CBA4}"/>
               </a:ext>
             </a:extLst>
           </p:cNvPr>
@@ -13195,7 +13195,7 @@
           <p:cNvPr id="9" name="item_1">
             <a:extLst>
               <a:ext uri="{FF2B5EF4-FFF2-40B4-BE49-F238E27FC236}">
-                <a16:creationId xmlns:a16="http://schemas.microsoft.com/office/drawing/2014/main" id="{4D9D7BA8-DA49-0540-89D2-2D1B5A20BB82}"/>
+                <a16:creationId xmlns:a16="http://schemas.microsoft.com/office/drawing/2014/main" id="{318D40DD-027C-CABA-7CED-9E58559D92A3}"/>
               </a:ext>
             </a:extLst>
           </p:cNvPr>
@@ -13243,7 +13243,7 @@
           <p:cNvPr id="10" name="item_2_title">
             <a:extLst>
               <a:ext uri="{FF2B5EF4-FFF2-40B4-BE49-F238E27FC236}">
-                <a16:creationId xmlns:a16="http://schemas.microsoft.com/office/drawing/2014/main" id="{9666D78D-38DC-69E4-EF20-44FC4EB3FE91}"/>
+                <a16:creationId xmlns:a16="http://schemas.microsoft.com/office/drawing/2014/main" id="{632F8B08-C0F7-1A35-D1B5-77832F6ABB1B}"/>
               </a:ext>
             </a:extLst>
           </p:cNvPr>
@@ -13296,7 +13296,7 @@
           <p:cNvPr id="11" name="item_2">
             <a:extLst>
               <a:ext uri="{FF2B5EF4-FFF2-40B4-BE49-F238E27FC236}">
-                <a16:creationId xmlns:a16="http://schemas.microsoft.com/office/drawing/2014/main" id="{F998E585-3088-C5EC-FC0E-D0C05782B85F}"/>
+                <a16:creationId xmlns:a16="http://schemas.microsoft.com/office/drawing/2014/main" id="{A4D0A8AB-3F94-F4E9-EF82-BF20BA730FF5}"/>
               </a:ext>
             </a:extLst>
           </p:cNvPr>
@@ -13344,7 +13344,7 @@
           <p:cNvPr id="12" name="item_3_title">
             <a:extLst>
               <a:ext uri="{FF2B5EF4-FFF2-40B4-BE49-F238E27FC236}">
-                <a16:creationId xmlns:a16="http://schemas.microsoft.com/office/drawing/2014/main" id="{514CB252-1897-E5A9-DDC3-5D8BC9D34956}"/>
+                <a16:creationId xmlns:a16="http://schemas.microsoft.com/office/drawing/2014/main" id="{0A409130-DC85-CA97-0E34-81FF6121F51C}"/>
               </a:ext>
             </a:extLst>
           </p:cNvPr>
@@ -13397,7 +13397,7 @@
           <p:cNvPr id="13" name="item_3">
             <a:extLst>
               <a:ext uri="{FF2B5EF4-FFF2-40B4-BE49-F238E27FC236}">
-                <a16:creationId xmlns:a16="http://schemas.microsoft.com/office/drawing/2014/main" id="{3B16A3FA-1218-E8FF-F1D2-36918E174B6F}"/>
+                <a16:creationId xmlns:a16="http://schemas.microsoft.com/office/drawing/2014/main" id="{40910E34-77C8-3E0C-4DEF-70873249469E}"/>
               </a:ext>
             </a:extLst>
           </p:cNvPr>
@@ -13445,7 +13445,7 @@
           <p:cNvPr id="14" name="item_4_title">
             <a:extLst>
               <a:ext uri="{FF2B5EF4-FFF2-40B4-BE49-F238E27FC236}">
-                <a16:creationId xmlns:a16="http://schemas.microsoft.com/office/drawing/2014/main" id="{F972FC8B-E0DB-904E-7DE7-1F18FA7BC341}"/>
+                <a16:creationId xmlns:a16="http://schemas.microsoft.com/office/drawing/2014/main" id="{08D18DE1-627A-2B61-CB01-49548F890AC4}"/>
               </a:ext>
             </a:extLst>
           </p:cNvPr>
@@ -13498,7 +13498,7 @@
           <p:cNvPr id="15" name="item_4">
             <a:extLst>
               <a:ext uri="{FF2B5EF4-FFF2-40B4-BE49-F238E27FC236}">
-                <a16:creationId xmlns:a16="http://schemas.microsoft.com/office/drawing/2014/main" id="{BF5FA7FC-A0F4-46DE-58AF-17298E60B971}"/>
+                <a16:creationId xmlns:a16="http://schemas.microsoft.com/office/drawing/2014/main" id="{07D9BAA3-A21C-1034-696A-0C1016E1DEF3}"/>
               </a:ext>
             </a:extLst>
           </p:cNvPr>
@@ -13546,7 +13546,7 @@
           <p:cNvPr id="16" name="source">
             <a:extLst>
               <a:ext uri="{FF2B5EF4-FFF2-40B4-BE49-F238E27FC236}">
-                <a16:creationId xmlns:a16="http://schemas.microsoft.com/office/drawing/2014/main" id="{E835007D-E4A6-B7AD-DA64-C93DE8A98408}"/>
+                <a16:creationId xmlns:a16="http://schemas.microsoft.com/office/drawing/2014/main" id="{F36CF909-7FD4-FD64-424F-749BFBE22FD4}"/>
               </a:ext>
             </a:extLst>
           </p:cNvPr>
@@ -13601,7 +13601,7 @@
     </p:spTree>
     <p:extLst>
       <p:ext uri="{BB962C8B-B14F-4D97-AF65-F5344CB8AC3E}">
-        <p14:creationId xmlns:p14="http://schemas.microsoft.com/office/powerpoint/2010/main" val="4176935507"/>
+        <p14:creationId xmlns:p14="http://schemas.microsoft.com/office/powerpoint/2010/main" val="2543116628"/>
       </p:ext>
     </p:extLst>
   </p:cSld>
@@ -13638,7 +13638,7 @@
           <p:cNvPr id="9" name="creative_background_master">
             <a:extLst>
               <a:ext uri="{FF2B5EF4-FFF2-40B4-BE49-F238E27FC236}">
-                <a16:creationId xmlns:a16="http://schemas.microsoft.com/office/drawing/2014/main" id="{D798BCFB-11A8-B5E2-5E6B-1B62FAE53A89}"/>
+                <a16:creationId xmlns:a16="http://schemas.microsoft.com/office/drawing/2014/main" id="{D553B35A-283F-2A6B-C2A6-15D6C3C60D38}"/>
               </a:ext>
             </a:extLst>
           </p:cNvPr>
@@ -13799,7 +13799,7 @@
             </a:lvl1pPr>
           </a:lstStyle>
           <a:p>
-            <a:fld id="{DA01C8C9-DA9E-4EB0-8756-652B0DE35A87}" type="datetimeFigureOut">
+            <a:fld id="{4E307407-BF02-4185-B795-8EFF67E65125}" type="datetimeFigureOut">
               <a:rPr lang="en-US" smtClean="0"/>
               <a:t>10/3/2026</a:t>
             </a:fld>
@@ -13881,7 +13881,7 @@
             </a:lvl1pPr>
           </a:lstStyle>
           <a:p>
-            <a:fld id="{E8DEFA18-2CFA-4775-9ECD-212CDF18C33F}" type="slidenum">
+            <a:fld id="{0901BA54-D28A-46F7-BDED-B9CC383D9A66}" type="slidenum">
               <a:rPr lang="en-US" smtClean="0"/>
               <a:t>‹#›</a:t>
             </a:fld>
@@ -13892,7 +13892,7 @@
     </p:spTree>
     <p:extLst>
       <p:ext uri="{BB962C8B-B14F-4D97-AF65-F5344CB8AC3E}">
-        <p14:creationId xmlns:p14="http://schemas.microsoft.com/office/powerpoint/2010/main" val="2058928684"/>
+        <p14:creationId xmlns:p14="http://schemas.microsoft.com/office/powerpoint/2010/main" val="2057657983"/>
       </p:ext>
     </p:extLst>
   </p:cSld>
@@ -14273,7 +14273,7 @@
   <a:themeElements>
     <a:clrScheme name="Integral">
       <a:dk1>
-        <a:srgbClr val="5F70D2"/>
+        <a:srgbClr val="6A7CE0"/>
       </a:dk1>
       <a:lt1>
         <a:srgbClr val="06070B"/>
@@ -14288,7 +14288,7 @@
         <a:srgbClr val="E0B85B"/>
       </a:accent1>
       <a:accent2>
-        <a:srgbClr val="5F70D2"/>
+        <a:srgbClr val="E0B85B"/>
       </a:accent2>
       <a:accent3>
         <a:srgbClr val="9EA4BA"/>

</xml_diff>